<commit_message>
Add a Glossary slide to every weekly deck
Each of the 10 weekly presentations (PDF + PPTX) now has a 'Glossary --
Key Terms' slide with ~7 week-specific terms (bold red term + plain
definition), placed before the Reading slide. Definitions are ASCII so the
Beamer decks compile without a Unicode header.

Co-Authored-By: Claude Opus 4.8 (1M context) <noreply@anthropic.com>
</commit_message>
<xml_diff>
--- a/weekly_presentations/week01_introduction.pptx
+++ b/weekly_presentations/week01_introduction.pptx
@@ -17,6 +17,7 @@
     <p:sldId id="265" r:id="rId16"/>
     <p:sldId id="266" r:id="rId17"/>
     <p:sldId id="267" r:id="rId18"/>
+    <p:sldId id="268" r:id="rId19"/>
   </p:sldIdLst>
   <p:sldSz cx="12191695" cy="6858000" type="screen4x3"/>
   <p:notesSz cx="6858000" cy="9144000"/>
@@ -4093,6 +4094,323 @@
 </file>
 
 <file path=ppt/slides/slide12.xml><?xml version="1.0" encoding="utf-8"?>
+<p:sld xmlns:a="http://schemas.openxmlformats.org/drawingml/2006/main" xmlns:p="http://schemas.openxmlformats.org/presentationml/2006/main" xmlns:r="http://schemas.openxmlformats.org/officeDocument/2006/relationships">
+  <p:cSld>
+    <p:spTree>
+      <p:nvGrpSpPr>
+        <p:cNvPr id="1" name=""/>
+        <p:cNvGrpSpPr/>
+        <p:nvPr/>
+      </p:nvGrpSpPr>
+      <p:grpSpPr/>
+      <p:pic>
+        <p:nvPicPr>
+          <p:cNvPr id="2" name="Picture 1" descr="ncsu_logo.png"/>
+          <p:cNvPicPr>
+            <a:picLocks noChangeAspect="1"/>
+          </p:cNvPicPr>
+          <p:nvPr/>
+        </p:nvPicPr>
+        <p:blipFill>
+          <a:blip r:embed="rId2"/>
+          <a:stretch>
+            <a:fillRect/>
+          </a:stretch>
+        </p:blipFill>
+        <p:spPr>
+          <a:xfrm>
+            <a:off x="9784080" y="274320"/>
+            <a:ext cx="2011680" cy="316653"/>
+          </a:xfrm>
+          <a:prstGeom prst="rect">
+            <a:avLst/>
+          </a:prstGeom>
+        </p:spPr>
+      </p:pic>
+      <p:sp>
+        <p:nvSpPr>
+          <p:cNvPr id="3" name="TextBox 2"/>
+          <p:cNvSpPr txBox="1"/>
+          <p:nvPr/>
+        </p:nvSpPr>
+        <p:spPr>
+          <a:xfrm>
+            <a:off x="457200" y="457200"/>
+            <a:ext cx="8961120" cy="822960"/>
+          </a:xfrm>
+          <a:prstGeom prst="rect">
+            <a:avLst/>
+          </a:prstGeom>
+          <a:noFill/>
+        </p:spPr>
+        <p:txBody>
+          <a:bodyPr wrap="none">
+            <a:spAutoFit/>
+          </a:bodyPr>
+          <a:lstStyle/>
+          <a:p>
+            <a:r>
+              <a:rPr sz="2400" b="1" i="0">
+                <a:solidFill>
+                  <a:srgbClr val="990000"/>
+                </a:solidFill>
+                <a:latin typeface="Arial"/>
+              </a:rPr>
+              <a:t>Glossary — Key Terms</a:t>
+            </a:r>
+          </a:p>
+        </p:txBody>
+      </p:sp>
+      <p:sp>
+        <p:nvSpPr>
+          <p:cNvPr id="4" name="Rectangle 3"/>
+          <p:cNvSpPr/>
+          <p:nvPr/>
+        </p:nvSpPr>
+        <p:spPr>
+          <a:xfrm>
+            <a:off x="457200" y="1371600"/>
+            <a:ext cx="11247120" cy="27940"/>
+          </a:xfrm>
+          <a:prstGeom prst="rect">
+            <a:avLst/>
+          </a:prstGeom>
+          <a:solidFill>
+            <a:srgbClr val="CC0000"/>
+          </a:solidFill>
+          <a:ln>
+            <a:noFill/>
+          </a:ln>
+        </p:spPr>
+        <p:style>
+          <a:lnRef idx="1">
+            <a:schemeClr val="accent1"/>
+          </a:lnRef>
+          <a:fillRef idx="3">
+            <a:schemeClr val="accent1"/>
+          </a:fillRef>
+          <a:effectRef idx="2">
+            <a:schemeClr val="accent1"/>
+          </a:effectRef>
+          <a:fontRef idx="minor">
+            <a:schemeClr val="lt1"/>
+          </a:fontRef>
+        </p:style>
+        <p:txBody>
+          <a:bodyPr rtlCol="0" anchor="ctr"/>
+          <a:lstStyle/>
+          <a:p>
+            <a:pPr algn="ctr"/>
+          </a:p>
+        </p:txBody>
+      </p:sp>
+      <p:sp>
+        <p:nvSpPr>
+          <p:cNvPr id="5" name="TextBox 4"/>
+          <p:cNvSpPr txBox="1"/>
+          <p:nvPr/>
+        </p:nvSpPr>
+        <p:spPr>
+          <a:xfrm>
+            <a:off x="640080" y="1600200"/>
+            <a:ext cx="10972800" cy="4937760"/>
+          </a:xfrm>
+          <a:prstGeom prst="rect">
+            <a:avLst/>
+          </a:prstGeom>
+          <a:noFill/>
+        </p:spPr>
+        <p:txBody>
+          <a:bodyPr wrap="square">
+            <a:spAutoFit/>
+          </a:bodyPr>
+          <a:lstStyle/>
+          <a:p>
+            <a:pPr>
+              <a:spcAft>
+                <a:spcPts val="700"/>
+              </a:spcAft>
+            </a:pPr>
+            <a:r>
+              <a:rPr sz="1500" b="1" i="0">
+                <a:solidFill>
+                  <a:srgbClr val="CC0000"/>
+                </a:solidFill>
+                <a:latin typeface="Arial"/>
+              </a:rPr>
+              <a:t>Market maker — </a:t>
+            </a:r>
+            <a:r>
+              <a:rPr sz="1500" b="0" i="0">
+                <a:solidFill>
+                  <a:srgbClr val="1A1A1A"/>
+                </a:solidFill>
+                <a:latin typeface="Arial"/>
+              </a:rPr>
+              <a:t>liquidity provider that continuously quotes bid and ask, earning the spread</a:t>
+            </a:r>
+          </a:p>
+          <a:p>
+            <a:pPr>
+              <a:spcAft>
+                <a:spcPts val="700"/>
+              </a:spcAft>
+            </a:pPr>
+            <a:r>
+              <a:rPr sz="1500" b="1" i="0">
+                <a:solidFill>
+                  <a:srgbClr val="CC0000"/>
+                </a:solidFill>
+                <a:latin typeface="Arial"/>
+              </a:rPr>
+              <a:t>Taker — </a:t>
+            </a:r>
+            <a:r>
+              <a:rPr sz="1500" b="0" i="0">
+                <a:solidFill>
+                  <a:srgbClr val="1A1A1A"/>
+                </a:solidFill>
+                <a:latin typeface="Arial"/>
+              </a:rPr>
+              <a:t>participant that crosses the spread for immediate execution</a:t>
+            </a:r>
+          </a:p>
+          <a:p>
+            <a:pPr>
+              <a:spcAft>
+                <a:spcPts val="700"/>
+              </a:spcAft>
+            </a:pPr>
+            <a:r>
+              <a:rPr sz="1500" b="1" i="0">
+                <a:solidFill>
+                  <a:srgbClr val="CC0000"/>
+                </a:solidFill>
+                <a:latin typeface="Arial"/>
+              </a:rPr>
+              <a:t>Bid-ask spread — </a:t>
+            </a:r>
+            <a:r>
+              <a:rPr sz="1500" b="0" i="0">
+                <a:solidFill>
+                  <a:srgbClr val="1A1A1A"/>
+                </a:solidFill>
+                <a:latin typeface="Arial"/>
+              </a:rPr>
+              <a:t>best ask minus best bid; the maker's revenue and risk premium</a:t>
+            </a:r>
+          </a:p>
+          <a:p>
+            <a:pPr>
+              <a:spcAft>
+                <a:spcPts val="700"/>
+              </a:spcAft>
+            </a:pPr>
+            <a:r>
+              <a:rPr sz="1500" b="1" i="0">
+                <a:solidFill>
+                  <a:srgbClr val="CC0000"/>
+                </a:solidFill>
+                <a:latin typeface="Arial"/>
+              </a:rPr>
+              <a:t>Inventory — </a:t>
+            </a:r>
+            <a:r>
+              <a:rPr sz="1500" b="0" i="0">
+                <a:solidFill>
+                  <a:srgbClr val="1A1A1A"/>
+                </a:solidFill>
+                <a:latin typeface="Arial"/>
+              </a:rPr>
+              <a:t>the maker's net position; the main source of risk</a:t>
+            </a:r>
+          </a:p>
+          <a:p>
+            <a:pPr>
+              <a:spcAft>
+                <a:spcPts val="700"/>
+              </a:spcAft>
+            </a:pPr>
+            <a:r>
+              <a:rPr sz="1500" b="1" i="0">
+                <a:solidFill>
+                  <a:srgbClr val="CC0000"/>
+                </a:solidFill>
+                <a:latin typeface="Arial"/>
+              </a:rPr>
+              <a:t>Milestone — </a:t>
+            </a:r>
+            <a:r>
+              <a:rPr sz="1500" b="0" i="0">
+                <a:solidFill>
+                  <a:srgbClr val="1A1A1A"/>
+                </a:solidFill>
+                <a:latin typeface="Arial"/>
+              </a:rPr>
+              <a:t>graded software deliverable, due in Weeks 5, 7, and 9</a:t>
+            </a:r>
+          </a:p>
+          <a:p>
+            <a:pPr>
+              <a:spcAft>
+                <a:spcPts val="700"/>
+              </a:spcAft>
+            </a:pPr>
+            <a:r>
+              <a:rPr sz="1500" b="1" i="0">
+                <a:solidFill>
+                  <a:srgbClr val="CC0000"/>
+                </a:solidFill>
+                <a:latin typeface="Arial"/>
+              </a:rPr>
+              <a:t>PyTorch / autograd — </a:t>
+            </a:r>
+            <a:r>
+              <a:rPr sz="1500" b="0" i="0">
+                <a:solidFill>
+                  <a:srgbClr val="1A1A1A"/>
+                </a:solidFill>
+                <a:latin typeface="Arial"/>
+              </a:rPr>
+              <a:t>Python ML library; automatic differentiation computes Greeks for you</a:t>
+            </a:r>
+          </a:p>
+          <a:p>
+            <a:pPr>
+              <a:spcAft>
+                <a:spcPts val="700"/>
+              </a:spcAft>
+            </a:pPr>
+            <a:r>
+              <a:rPr sz="1500" b="1" i="0">
+                <a:solidFill>
+                  <a:srgbClr val="CC0000"/>
+                </a:solidFill>
+                <a:latin typeface="Arial"/>
+              </a:rPr>
+              <a:t>pybind11 — </a:t>
+            </a:r>
+            <a:r>
+              <a:rPr sz="1500" b="0" i="0">
+                <a:solidFill>
+                  <a:srgbClr val="1A1A1A"/>
+                </a:solidFill>
+                <a:latin typeface="Arial"/>
+              </a:rPr>
+              <a:t>library that exposes C++ functions to Python (used in Week 7)</a:t>
+            </a:r>
+          </a:p>
+        </p:txBody>
+      </p:sp>
+    </p:spTree>
+  </p:cSld>
+  <p:clrMapOvr>
+    <a:masterClrMapping/>
+  </p:clrMapOvr>
+</p:sld>
+</file>
+
+<file path=ppt/slides/slide13.xml><?xml version="1.0" encoding="utf-8"?>
 <p:sld xmlns:a="http://schemas.openxmlformats.org/drawingml/2006/main" xmlns:p="http://schemas.openxmlformats.org/presentationml/2006/main" xmlns:r="http://schemas.openxmlformats.org/officeDocument/2006/relationships">
   <p:cSld>
     <p:spTree>

</xml_diff>

<commit_message>
Add a References slide to every weekly deck
Each of the 10 weekly presentations (PDF + PPTX) now ends with a
'References' slide of full citations relevant to that week (primary
sources, plus the Coincall API docs and the pybind11/PyTorch references
where used). ASCII-only so the Beamer decks compile without a Unicode
header.

Co-Authored-By: Claude Opus 4.8 (1M context) <noreply@anthropic.com>
</commit_message>
<xml_diff>
--- a/weekly_presentations/week01_introduction.pptx
+++ b/weekly_presentations/week01_introduction.pptx
@@ -18,6 +18,7 @@
     <p:sldId id="266" r:id="rId17"/>
     <p:sldId id="267" r:id="rId18"/>
     <p:sldId id="268" r:id="rId19"/>
+    <p:sldId id="269" r:id="rId20"/>
   </p:sldIdLst>
   <p:sldSz cx="12191695" cy="6858000" type="screen4x3"/>
   <p:notesSz cx="6858000" cy="9144000"/>
@@ -4572,6 +4573,212 @@
                 <a:latin typeface="Arial"/>
               </a:rPr>
               <a:t>•  Coincall API docs: https://docs.coincall.com/  (read 'Getting Started')</a:t>
+            </a:r>
+          </a:p>
+        </p:txBody>
+      </p:sp>
+    </p:spTree>
+  </p:cSld>
+  <p:clrMapOvr>
+    <a:masterClrMapping/>
+  </p:clrMapOvr>
+</p:sld>
+</file>
+
+<file path=ppt/slides/slide14.xml><?xml version="1.0" encoding="utf-8"?>
+<p:sld xmlns:a="http://schemas.openxmlformats.org/drawingml/2006/main" xmlns:p="http://schemas.openxmlformats.org/presentationml/2006/main" xmlns:r="http://schemas.openxmlformats.org/officeDocument/2006/relationships">
+  <p:cSld>
+    <p:spTree>
+      <p:nvGrpSpPr>
+        <p:cNvPr id="1" name=""/>
+        <p:cNvGrpSpPr/>
+        <p:nvPr/>
+      </p:nvGrpSpPr>
+      <p:grpSpPr/>
+      <p:pic>
+        <p:nvPicPr>
+          <p:cNvPr id="2" name="Picture 1" descr="ncsu_logo.png"/>
+          <p:cNvPicPr>
+            <a:picLocks noChangeAspect="1"/>
+          </p:cNvPicPr>
+          <p:nvPr/>
+        </p:nvPicPr>
+        <p:blipFill>
+          <a:blip r:embed="rId2"/>
+          <a:stretch>
+            <a:fillRect/>
+          </a:stretch>
+        </p:blipFill>
+        <p:spPr>
+          <a:xfrm>
+            <a:off x="9784080" y="274320"/>
+            <a:ext cx="2011680" cy="316653"/>
+          </a:xfrm>
+          <a:prstGeom prst="rect">
+            <a:avLst/>
+          </a:prstGeom>
+        </p:spPr>
+      </p:pic>
+      <p:sp>
+        <p:nvSpPr>
+          <p:cNvPr id="3" name="TextBox 2"/>
+          <p:cNvSpPr txBox="1"/>
+          <p:nvPr/>
+        </p:nvSpPr>
+        <p:spPr>
+          <a:xfrm>
+            <a:off x="457200" y="457200"/>
+            <a:ext cx="8961120" cy="822960"/>
+          </a:xfrm>
+          <a:prstGeom prst="rect">
+            <a:avLst/>
+          </a:prstGeom>
+          <a:noFill/>
+        </p:spPr>
+        <p:txBody>
+          <a:bodyPr wrap="square">
+            <a:spAutoFit/>
+          </a:bodyPr>
+          <a:lstStyle/>
+          <a:p>
+            <a:r>
+              <a:rPr sz="2400" b="1" i="0">
+                <a:solidFill>
+                  <a:srgbClr val="990000"/>
+                </a:solidFill>
+                <a:latin typeface="Arial"/>
+              </a:rPr>
+              <a:t>References</a:t>
+            </a:r>
+          </a:p>
+        </p:txBody>
+      </p:sp>
+      <p:sp>
+        <p:nvSpPr>
+          <p:cNvPr id="4" name="Rectangle 3"/>
+          <p:cNvSpPr/>
+          <p:nvPr/>
+        </p:nvSpPr>
+        <p:spPr>
+          <a:xfrm>
+            <a:off x="457200" y="1371600"/>
+            <a:ext cx="11247120" cy="27940"/>
+          </a:xfrm>
+          <a:prstGeom prst="rect">
+            <a:avLst/>
+          </a:prstGeom>
+          <a:solidFill>
+            <a:srgbClr val="CC0000"/>
+          </a:solidFill>
+          <a:ln>
+            <a:noFill/>
+          </a:ln>
+        </p:spPr>
+        <p:style>
+          <a:lnRef idx="1">
+            <a:schemeClr val="accent1"/>
+          </a:lnRef>
+          <a:fillRef idx="3">
+            <a:schemeClr val="accent1"/>
+          </a:fillRef>
+          <a:effectRef idx="2">
+            <a:schemeClr val="accent1"/>
+          </a:effectRef>
+          <a:fontRef idx="minor">
+            <a:schemeClr val="lt1"/>
+          </a:fontRef>
+        </p:style>
+        <p:txBody>
+          <a:bodyPr rtlCol="0" anchor="ctr"/>
+          <a:lstStyle/>
+          <a:p>
+            <a:pPr algn="ctr"/>
+          </a:p>
+        </p:txBody>
+      </p:sp>
+      <p:sp>
+        <p:nvSpPr>
+          <p:cNvPr id="5" name="TextBox 4"/>
+          <p:cNvSpPr txBox="1"/>
+          <p:nvPr/>
+        </p:nvSpPr>
+        <p:spPr>
+          <a:xfrm>
+            <a:off x="640080" y="1600200"/>
+            <a:ext cx="10972800" cy="4937760"/>
+          </a:xfrm>
+          <a:prstGeom prst="rect">
+            <a:avLst/>
+          </a:prstGeom>
+          <a:noFill/>
+        </p:spPr>
+        <p:txBody>
+          <a:bodyPr wrap="square">
+            <a:spAutoFit/>
+          </a:bodyPr>
+          <a:lstStyle/>
+          <a:p>
+            <a:pPr>
+              <a:spcAft>
+                <a:spcPts val="500"/>
+              </a:spcAft>
+            </a:pPr>
+            <a:r>
+              <a:rPr sz="1200" b="0" i="0">
+                <a:solidFill>
+                  <a:srgbClr val="1A1A1A"/>
+                </a:solidFill>
+                <a:latin typeface="Arial"/>
+              </a:rPr>
+              <a:t>•  Avellaneda, M., &amp; Stoikov, S. (2008). High-frequency trading in a limit order book. Quantitative Finance, 8(3), 217-224.</a:t>
+            </a:r>
+          </a:p>
+          <a:p>
+            <a:pPr>
+              <a:spcAft>
+                <a:spcPts val="500"/>
+              </a:spcAft>
+            </a:pPr>
+            <a:r>
+              <a:rPr sz="1200" b="0" i="0">
+                <a:solidFill>
+                  <a:srgbClr val="1A1A1A"/>
+                </a:solidFill>
+                <a:latin typeface="Arial"/>
+              </a:rPr>
+              <a:t>•  Gueant, O. (2016). The Financial Mathematics of Market Liquidity. Chapman &amp; Hall/CRC.</a:t>
+            </a:r>
+          </a:p>
+          <a:p>
+            <a:pPr>
+              <a:spcAft>
+                <a:spcPts val="500"/>
+              </a:spcAft>
+            </a:pPr>
+            <a:r>
+              <a:rPr sz="1200" b="0" i="0">
+                <a:solidFill>
+                  <a:srgbClr val="1A1A1A"/>
+                </a:solidFill>
+                <a:latin typeface="Arial"/>
+              </a:rPr>
+              <a:t>•  Cartea, A., Jaikumar, S., &amp; Penalva, J. (2015). Algorithmic and High-Frequency Trading. Cambridge Univ. Press.</a:t>
+            </a:r>
+          </a:p>
+          <a:p>
+            <a:pPr>
+              <a:spcAft>
+                <a:spcPts val="500"/>
+              </a:spcAft>
+            </a:pPr>
+            <a:r>
+              <a:rPr sz="1200" b="0" i="0">
+                <a:solidFill>
+                  <a:srgbClr val="1A1A1A"/>
+                </a:solidFill>
+                <a:latin typeface="Arial"/>
+              </a:rPr>
+              <a:t>•  Coincall API documentation. https://docs.coincall.com/</a:t>
             </a:r>
           </a:p>
         </p:txBody>

</xml_diff>

<commit_message>
Add a Contents (table of contents) slide to every weekly deck
Each weekly deck (PDF + PPTX) now has a 'Contents' slide right after the
title, generated from that week's actual sections (objectives, the two
lectures, any Week-1 extras, illustration, derivation if present, Coincall
data, code, glossary, reading, references).

Co-Authored-By: Claude Opus 4.8 (1M context) <noreply@anthropic.com>
</commit_message>
<xml_diff>
--- a/weekly_presentations/week01_introduction.pptx
+++ b/weekly_presentations/week01_introduction.pptx
@@ -19,6 +19,7 @@
     <p:sldId id="267" r:id="rId18"/>
     <p:sldId id="268" r:id="rId19"/>
     <p:sldId id="269" r:id="rId20"/>
+    <p:sldId id="270" r:id="rId21"/>
   </p:sldIdLst>
   <p:sldSz cx="12191695" cy="6858000" type="screen4x3"/>
   <p:notesSz cx="6858000" cy="9144000"/>
@@ -3281,7 +3282,7 @@
         </p:blipFill>
         <p:spPr>
           <a:xfrm>
-            <a:off x="9784080" y="274320"/>
+            <a:off x="9784080" y="228600"/>
             <a:ext cx="2011680" cy="316653"/>
           </a:xfrm>
           <a:prstGeom prst="rect">
@@ -3297,8 +3298,8 @@
         </p:nvSpPr>
         <p:spPr>
           <a:xfrm>
-            <a:off x="457200" y="457200"/>
-            <a:ext cx="8961120" cy="822960"/>
+            <a:off x="457200" y="411480"/>
+            <a:ext cx="8961120" cy="731520"/>
           </a:xfrm>
           <a:prstGeom prst="rect">
             <a:avLst/>
@@ -3306,340 +3307,47 @@
           <a:noFill/>
         </p:spPr>
         <p:txBody>
-          <a:bodyPr wrap="square">
+          <a:bodyPr wrap="none">
             <a:spAutoFit/>
           </a:bodyPr>
           <a:lstStyle/>
           <a:p>
             <a:r>
-              <a:rPr sz="2400" b="1" i="0">
+              <a:rPr sz="2200" b="1" i="0">
                 <a:solidFill>
                   <a:srgbClr val="990000"/>
                 </a:solidFill>
                 <a:latin typeface="Arial"/>
               </a:rPr>
-              <a:t>Getting the Data from Coincall</a:t>
-            </a:r>
-          </a:p>
-          <a:p>
-            <a:r>
-              <a:rPr sz="1300" b="0" i="1">
-                <a:solidFill>
-                  <a:srgbClr val="6D6D6D"/>
-                </a:solidFill>
-                <a:latin typeface="Arial"/>
-              </a:rPr>
-              <a:t>Cross-check exact paths at https://docs.coincall.com/</a:t>
-            </a:r>
-          </a:p>
-        </p:txBody>
-      </p:sp>
-      <p:sp>
-        <p:nvSpPr>
-          <p:cNvPr id="4" name="Rectangle 3"/>
-          <p:cNvSpPr/>
+              <a:t>Illustration</a:t>
+            </a:r>
+          </a:p>
+        </p:txBody>
+      </p:sp>
+      <p:pic>
+        <p:nvPicPr>
+          <p:cNvPr id="4" name="Picture 3" descr="week01.png"/>
+          <p:cNvPicPr>
+            <a:picLocks noChangeAspect="1"/>
+          </p:cNvPicPr>
           <p:nvPr/>
-        </p:nvSpPr>
-        <p:spPr>
-          <a:xfrm>
-            <a:off x="457200" y="1371600"/>
-            <a:ext cx="11247120" cy="27940"/>
+        </p:nvPicPr>
+        <p:blipFill>
+          <a:blip r:embed="rId3"/>
+          <a:stretch>
+            <a:fillRect/>
+          </a:stretch>
+        </p:blipFill>
+        <p:spPr>
+          <a:xfrm>
+            <a:off x="1280160" y="1371600"/>
+            <a:ext cx="9601200" cy="5249525"/>
           </a:xfrm>
           <a:prstGeom prst="rect">
             <a:avLst/>
           </a:prstGeom>
-          <a:solidFill>
-            <a:srgbClr val="CC0000"/>
-          </a:solidFill>
-          <a:ln>
-            <a:noFill/>
-          </a:ln>
-        </p:spPr>
-        <p:style>
-          <a:lnRef idx="1">
-            <a:schemeClr val="accent1"/>
-          </a:lnRef>
-          <a:fillRef idx="3">
-            <a:schemeClr val="accent1"/>
-          </a:fillRef>
-          <a:effectRef idx="2">
-            <a:schemeClr val="accent1"/>
-          </a:effectRef>
-          <a:fontRef idx="minor">
-            <a:schemeClr val="lt1"/>
-          </a:fontRef>
-        </p:style>
-        <p:txBody>
-          <a:bodyPr rtlCol="0" anchor="ctr"/>
-          <a:lstStyle/>
-          <a:p>
-            <a:pPr algn="ctr"/>
-          </a:p>
-        </p:txBody>
-      </p:sp>
-      <p:sp>
-        <p:nvSpPr>
-          <p:cNvPr id="5" name="TextBox 4"/>
-          <p:cNvSpPr txBox="1"/>
-          <p:nvPr/>
-        </p:nvSpPr>
-        <p:spPr>
-          <a:xfrm>
-            <a:off x="640080" y="1600200"/>
-            <a:ext cx="10972800" cy="4937760"/>
-          </a:xfrm>
-          <a:prstGeom prst="rect">
-            <a:avLst/>
-          </a:prstGeom>
-          <a:noFill/>
-        </p:spPr>
-        <p:txBody>
-          <a:bodyPr wrap="square">
-            <a:spAutoFit/>
-          </a:bodyPr>
-          <a:lstStyle/>
-          <a:p>
-            <a:pPr>
-              <a:spcAft>
-                <a:spcPts val="500"/>
-              </a:spcAft>
-            </a:pPr>
-            <a:r>
-              <a:rPr sz="1200" b="0" i="0">
-                <a:solidFill>
-                  <a:srgbClr val="1A1A1A"/>
-                </a:solidFill>
-                <a:latin typeface="Arial"/>
-              </a:rPr>
-              <a:t>•  Base URL: https://api.coincall.com   |   Python SDK: github.com/CoincallExchange</a:t>
-            </a:r>
-          </a:p>
-          <a:p>
-            <a:pPr>
-              <a:spcAft>
-                <a:spcPts val="500"/>
-              </a:spcAft>
-            </a:pPr>
-            <a:r>
-              <a:rPr sz="1200" b="0" i="0">
-                <a:solidFill>
-                  <a:srgbClr val="1A1A1A"/>
-                </a:solidFill>
-                <a:latin typeface="Arial"/>
-              </a:rPr>
-              <a:t>•  Signed request headers: X-CC-APIKEY, sign (HMAC-SHA256, upper hex), ts (ms), X-REQ-TS-DIFF</a:t>
-            </a:r>
-          </a:p>
-          <a:p>
-            <a:pPr>
-              <a:spcAft>
-                <a:spcPts val="500"/>
-              </a:spcAft>
-            </a:pPr>
-            <a:r>
-              <a:rPr sz="1200" b="0" i="0">
-                <a:solidFill>
-                  <a:srgbClr val="1A1A1A"/>
-                </a:solidFill>
-                <a:latin typeface="Arial"/>
-              </a:rPr>
-              <a:t>•  Signing: sort params alphabetically, append uuid, ts, x-req-ts-diff, HMAC-SHA256 with secret</a:t>
-            </a:r>
-          </a:p>
-          <a:p>
-            <a:pPr>
-              <a:spcAft>
-                <a:spcPts val="500"/>
-              </a:spcAft>
-            </a:pPr>
-            <a:r>
-              <a:rPr sz="1200" b="0" i="0">
-                <a:solidFill>
-                  <a:srgbClr val="1A1A1A"/>
-                </a:solidFill>
-                <a:latin typeface="Arial"/>
-              </a:rPr>
-              <a:t>•  Rate limits (per docs): orderbook 30/2s per user; public config 10/2s per IP</a:t>
-            </a:r>
-          </a:p>
-          <a:p>
-            <a:pPr>
-              <a:spcAft>
-                <a:spcPts val="500"/>
-              </a:spcAft>
-            </a:pPr>
-            <a:r>
-              <a:rPr sz="1200" b="0" i="0">
-                <a:solidFill>
-                  <a:srgbClr val="1A1A1A"/>
-                </a:solidFill>
-                <a:latin typeface="Arial"/>
-              </a:rPr>
-              <a:t>•  Key endpoints you will use across the program:</a:t>
-            </a:r>
-          </a:p>
-          <a:p>
-            <a:pPr>
-              <a:spcAft>
-                <a:spcPts val="500"/>
-              </a:spcAft>
-            </a:pPr>
-            <a:r>
-              <a:rPr sz="1200" b="0" i="0">
-                <a:solidFill>
-                  <a:srgbClr val="1A1A1A"/>
-                </a:solidFill>
-                <a:latin typeface="Consolas"/>
-              </a:rPr>
-              <a:t>    Instruments:   GET /open/option/getInstruments/{baseCurrency}</a:t>
-            </a:r>
-          </a:p>
-          <a:p>
-            <a:pPr>
-              <a:spcAft>
-                <a:spcPts val="500"/>
-              </a:spcAft>
-            </a:pPr>
-            <a:r>
-              <a:rPr sz="1200" b="0" i="0">
-                <a:solidFill>
-                  <a:srgbClr val="1A1A1A"/>
-                </a:solidFill>
-                <a:latin typeface="Consolas"/>
-              </a:rPr>
-              <a:t>    Option chain:  GET /open/option/get/v1/{index}</a:t>
-            </a:r>
-          </a:p>
-          <a:p>
-            <a:pPr>
-              <a:spcAft>
-                <a:spcPts val="500"/>
-              </a:spcAft>
-            </a:pPr>
-            <a:r>
-              <a:rPr sz="1200" b="0" i="0">
-                <a:solidFill>
-                  <a:srgbClr val="1A1A1A"/>
-                </a:solidFill>
-                <a:latin typeface="Consolas"/>
-              </a:rPr>
-              <a:t>    Option book:   GET /open/option/order/orderbook/v1/{symbol}  (100 depth)</a:t>
-            </a:r>
-          </a:p>
-          <a:p>
-            <a:pPr>
-              <a:spcAft>
-                <a:spcPts val="500"/>
-              </a:spcAft>
-            </a:pPr>
-            <a:r>
-              <a:rPr sz="1200" b="0" i="0">
-                <a:solidFill>
-                  <a:srgbClr val="1A1A1A"/>
-                </a:solidFill>
-                <a:latin typeface="Consolas"/>
-              </a:rPr>
-              <a:t>    Option detail: GET /open/option/detail/v1/{symbol}  (mark, IV, delta/gamma/vega/theta)</a:t>
-            </a:r>
-          </a:p>
-          <a:p>
-            <a:pPr>
-              <a:spcAft>
-                <a:spcPts val="500"/>
-              </a:spcAft>
-            </a:pPr>
-            <a:r>
-              <a:rPr sz="1200" b="0" i="0">
-                <a:solidFill>
-                  <a:srgbClr val="1A1A1A"/>
-                </a:solidFill>
-                <a:latin typeface="Consolas"/>
-              </a:rPr>
-              <a:t>    Trades:        GET /open/option/trade/lasttrade/v1/{symbol}</a:t>
-            </a:r>
-          </a:p>
-          <a:p>
-            <a:pPr>
-              <a:spcAft>
-                <a:spcPts val="500"/>
-              </a:spcAft>
-            </a:pPr>
-            <a:r>
-              <a:rPr sz="1200" b="0" i="0">
-                <a:solidFill>
-                  <a:srgbClr val="1A1A1A"/>
-                </a:solidFill>
-                <a:latin typeface="Consolas"/>
-              </a:rPr>
-              <a:t>    Futures book:  GET /open/futures/order/orderbook/v1/{symbol}</a:t>
-            </a:r>
-          </a:p>
-          <a:p>
-            <a:pPr>
-              <a:spcAft>
-                <a:spcPts val="500"/>
-              </a:spcAft>
-            </a:pPr>
-            <a:r>
-              <a:rPr sz="1200" b="0" i="0">
-                <a:solidFill>
-                  <a:srgbClr val="1A1A1A"/>
-                </a:solidFill>
-                <a:latin typeface="Consolas"/>
-              </a:rPr>
-              <a:t>    Funding:       GET /open/public/fundingRate/v1?symbol=BTCUSD</a:t>
-            </a:r>
-          </a:p>
-          <a:p>
-            <a:pPr>
-              <a:spcAft>
-                <a:spcPts val="500"/>
-              </a:spcAft>
-            </a:pPr>
-            <a:r>
-              <a:rPr sz="1200" b="0" i="0">
-                <a:solidFill>
-                  <a:srgbClr val="1A1A1A"/>
-                </a:solidFill>
-                <a:latin typeface="Consolas"/>
-              </a:rPr>
-              <a:t>    Klines:        GET /open/option/market/kline/history/v1/{optionName}?period=h1</a:t>
-            </a:r>
-          </a:p>
-          <a:p>
-            <a:pPr>
-              <a:spcAft>
-                <a:spcPts val="500"/>
-              </a:spcAft>
-            </a:pPr>
-            <a:r>
-              <a:rPr sz="1200" b="0" i="0">
-                <a:solidFill>
-                  <a:srgbClr val="1A1A1A"/>
-                </a:solidFill>
-                <a:latin typeface="Arial"/>
-              </a:rPr>
-              <a:t>•  WebSocket channels: /options/pricing, /options/orderbook, /options/lasttrade, /options/kline</a:t>
-            </a:r>
-          </a:p>
-          <a:p>
-            <a:pPr>
-              <a:spcAft>
-                <a:spcPts val="500"/>
-              </a:spcAft>
-            </a:pPr>
-            <a:r>
-              <a:rPr sz="1200" b="0" i="0">
-                <a:solidFill>
-                  <a:srgbClr val="1A1A1A"/>
-                </a:solidFill>
-                <a:latin typeface="Arial"/>
-              </a:rPr>
-              <a:t>•  ALWAYS verify the exact path/params against https://docs.coincall.com/ -- the API evolves.</a:t>
-            </a:r>
-          </a:p>
-        </p:txBody>
-      </p:sp>
+        </p:spPr>
+      </p:pic>
     </p:spTree>
   </p:cSld>
   <p:clrMapOvr>
@@ -3649,452 +3357,6 @@
 </file>
 
 <file path=ppt/slides/slide11.xml><?xml version="1.0" encoding="utf-8"?>
-<p:sld xmlns:a="http://schemas.openxmlformats.org/drawingml/2006/main" xmlns:p="http://schemas.openxmlformats.org/presentationml/2006/main" xmlns:r="http://schemas.openxmlformats.org/officeDocument/2006/relationships">
-  <p:cSld>
-    <p:spTree>
-      <p:nvGrpSpPr>
-        <p:cNvPr id="1" name=""/>
-        <p:cNvGrpSpPr/>
-        <p:nvPr/>
-      </p:nvGrpSpPr>
-      <p:grpSpPr/>
-      <p:sp>
-        <p:nvSpPr>
-          <p:cNvPr id="2" name="TextBox 1"/>
-          <p:cNvSpPr txBox="1"/>
-          <p:nvPr/>
-        </p:nvSpPr>
-        <p:spPr>
-          <a:xfrm>
-            <a:off x="457200" y="365760"/>
-            <a:ext cx="11247120" cy="640080"/>
-          </a:xfrm>
-          <a:prstGeom prst="rect">
-            <a:avLst/>
-          </a:prstGeom>
-          <a:noFill/>
-        </p:spPr>
-        <p:txBody>
-          <a:bodyPr wrap="none">
-            <a:spAutoFit/>
-          </a:bodyPr>
-          <a:lstStyle/>
-          <a:p>
-            <a:r>
-              <a:rPr sz="1800" b="1" i="0">
-                <a:solidFill>
-                  <a:srgbClr val="990000"/>
-                </a:solidFill>
-                <a:latin typeface="Arial"/>
-              </a:rPr>
-              <a:t>Code — coincall_client.py -- signed REST helper (verify signing vs. live docs)</a:t>
-            </a:r>
-          </a:p>
-        </p:txBody>
-      </p:sp>
-      <p:sp>
-        <p:nvSpPr>
-          <p:cNvPr id="3" name="Rectangle 2"/>
-          <p:cNvSpPr/>
-          <p:nvPr/>
-        </p:nvSpPr>
-        <p:spPr>
-          <a:xfrm>
-            <a:off x="457200" y="1097280"/>
-            <a:ext cx="11247120" cy="5394960"/>
-          </a:xfrm>
-          <a:prstGeom prst="rect">
-            <a:avLst/>
-          </a:prstGeom>
-          <a:solidFill>
-            <a:srgbClr val="F5F5F5"/>
-          </a:solidFill>
-          <a:ln w="9525">
-            <a:solidFill>
-              <a:srgbClr val="6D6D6D"/>
-            </a:solidFill>
-          </a:ln>
-        </p:spPr>
-        <p:style>
-          <a:lnRef idx="1">
-            <a:schemeClr val="accent1"/>
-          </a:lnRef>
-          <a:fillRef idx="3">
-            <a:schemeClr val="accent1"/>
-          </a:fillRef>
-          <a:effectRef idx="2">
-            <a:schemeClr val="accent1"/>
-          </a:effectRef>
-          <a:fontRef idx="minor">
-            <a:schemeClr val="lt1"/>
-          </a:fontRef>
-        </p:style>
-        <p:txBody>
-          <a:bodyPr rtlCol="0" anchor="ctr" wrap="square" lIns="182880" tIns="91440"/>
-          <a:lstStyle/>
-          <a:p>
-            <a:pPr algn="ctr">
-              <a:spcAft>
-                <a:spcPts val="0"/>
-              </a:spcAft>
-            </a:pPr>
-            <a:r>
-              <a:rPr sz="1100" b="0" i="0">
-                <a:solidFill>
-                  <a:srgbClr val="1A1A1A"/>
-                </a:solidFill>
-                <a:latin typeface="Consolas"/>
-              </a:rPr>
-              <a:t>import time, hmac, hashlib, uuid, requests</a:t>
-            </a:r>
-          </a:p>
-          <a:p>
-            <a:pPr>
-              <a:spcAft>
-                <a:spcPts val="0"/>
-              </a:spcAft>
-            </a:pPr>
-            <a:r>
-              <a:rPr sz="1100" b="0" i="0">
-                <a:solidFill>
-                  <a:srgbClr val="1A1A1A"/>
-                </a:solidFill>
-                <a:latin typeface="Consolas"/>
-              </a:rPr>
-              <a:t> </a:t>
-            </a:r>
-          </a:p>
-          <a:p>
-            <a:pPr>
-              <a:spcAft>
-                <a:spcPts val="0"/>
-              </a:spcAft>
-            </a:pPr>
-            <a:r>
-              <a:rPr sz="1100" b="0" i="0">
-                <a:solidFill>
-                  <a:srgbClr val="1A1A1A"/>
-                </a:solidFill>
-                <a:latin typeface="Consolas"/>
-              </a:rPr>
-              <a:t>BASE = "https://api.coincall.com"</a:t>
-            </a:r>
-          </a:p>
-          <a:p>
-            <a:pPr>
-              <a:spcAft>
-                <a:spcPts val="0"/>
-              </a:spcAft>
-            </a:pPr>
-            <a:r>
-              <a:rPr sz="1100" b="0" i="0">
-                <a:solidFill>
-                  <a:srgbClr val="1A1A1A"/>
-                </a:solidFill>
-                <a:latin typeface="Consolas"/>
-              </a:rPr>
-              <a:t> </a:t>
-            </a:r>
-          </a:p>
-          <a:p>
-            <a:pPr>
-              <a:spcAft>
-                <a:spcPts val="0"/>
-              </a:spcAft>
-            </a:pPr>
-            <a:r>
-              <a:rPr sz="1100" b="0" i="0">
-                <a:solidFill>
-                  <a:srgbClr val="1A1A1A"/>
-                </a:solidFill>
-                <a:latin typeface="Consolas"/>
-              </a:rPr>
-              <a:t>def signed_get(path, params=None, api_key="", api_secret=""):</a:t>
-            </a:r>
-          </a:p>
-          <a:p>
-            <a:pPr>
-              <a:spcAft>
-                <a:spcPts val="0"/>
-              </a:spcAft>
-            </a:pPr>
-            <a:r>
-              <a:rPr sz="1100" b="0" i="0">
-                <a:solidFill>
-                  <a:srgbClr val="1A1A1A"/>
-                </a:solidFill>
-                <a:latin typeface="Consolas"/>
-              </a:rPr>
-              <a:t>    """Minimal Coincall signed GET. Public market-data endpoints often work</a:t>
-            </a:r>
-          </a:p>
-          <a:p>
-            <a:pPr>
-              <a:spcAft>
-                <a:spcPts val="0"/>
-              </a:spcAft>
-            </a:pPr>
-            <a:r>
-              <a:rPr sz="1100" b="0" i="0">
-                <a:solidFill>
-                  <a:srgbClr val="1A1A1A"/>
-                </a:solidFill>
-                <a:latin typeface="Consolas"/>
-              </a:rPr>
-              <a:t>    unsigned; this shows the signed pattern used for account endpoints."""</a:t>
-            </a:r>
-          </a:p>
-          <a:p>
-            <a:pPr>
-              <a:spcAft>
-                <a:spcPts val="0"/>
-              </a:spcAft>
-            </a:pPr>
-            <a:r>
-              <a:rPr sz="1100" b="0" i="0">
-                <a:solidFill>
-                  <a:srgbClr val="1A1A1A"/>
-                </a:solidFill>
-                <a:latin typeface="Consolas"/>
-              </a:rPr>
-              <a:t>    params = params or {}</a:t>
-            </a:r>
-          </a:p>
-          <a:p>
-            <a:pPr>
-              <a:spcAft>
-                <a:spcPts val="0"/>
-              </a:spcAft>
-            </a:pPr>
-            <a:r>
-              <a:rPr sz="1100" b="0" i="0">
-                <a:solidFill>
-                  <a:srgbClr val="1A1A1A"/>
-                </a:solidFill>
-                <a:latin typeface="Consolas"/>
-              </a:rPr>
-              <a:t>    ts, window = str(int(time.time() * 1000)), "5000"</a:t>
-            </a:r>
-          </a:p>
-          <a:p>
-            <a:pPr>
-              <a:spcAft>
-                <a:spcPts val="0"/>
-              </a:spcAft>
-            </a:pPr>
-            <a:r>
-              <a:rPr sz="1100" b="0" i="0">
-                <a:solidFill>
-                  <a:srgbClr val="1A1A1A"/>
-                </a:solidFill>
-                <a:latin typeface="Consolas"/>
-              </a:rPr>
-              <a:t>    items = sorted(params.items())                       # sort alphabetically</a:t>
-            </a:r>
-          </a:p>
-          <a:p>
-            <a:pPr>
-              <a:spcAft>
-                <a:spcPts val="0"/>
-              </a:spcAft>
-            </a:pPr>
-            <a:r>
-              <a:rPr sz="1100" b="0" i="0">
-                <a:solidFill>
-                  <a:srgbClr val="1A1A1A"/>
-                </a:solidFill>
-                <a:latin typeface="Consolas"/>
-              </a:rPr>
-              <a:t>    payload = "&amp;".join(f"{k}={v}" for k, v in items)</a:t>
-            </a:r>
-          </a:p>
-          <a:p>
-            <a:pPr>
-              <a:spcAft>
-                <a:spcPts val="0"/>
-              </a:spcAft>
-            </a:pPr>
-            <a:r>
-              <a:rPr sz="1100" b="0" i="0">
-                <a:solidFill>
-                  <a:srgbClr val="1A1A1A"/>
-                </a:solidFill>
-                <a:latin typeface="Consolas"/>
-              </a:rPr>
-              <a:t>    payload += f"&amp;uuid={uuid.uuid4().hex}&amp;ts={ts}&amp;x-req-ts-diff={window}"</a:t>
-            </a:r>
-          </a:p>
-          <a:p>
-            <a:pPr>
-              <a:spcAft>
-                <a:spcPts val="0"/>
-              </a:spcAft>
-            </a:pPr>
-            <a:r>
-              <a:rPr sz="1100" b="0" i="0">
-                <a:solidFill>
-                  <a:srgbClr val="1A1A1A"/>
-                </a:solidFill>
-                <a:latin typeface="Consolas"/>
-              </a:rPr>
-              <a:t>    sign = hmac.new(api_secret.encode(), payload.encode(),</a:t>
-            </a:r>
-          </a:p>
-          <a:p>
-            <a:pPr>
-              <a:spcAft>
-                <a:spcPts val="0"/>
-              </a:spcAft>
-            </a:pPr>
-            <a:r>
-              <a:rPr sz="1100" b="0" i="0">
-                <a:solidFill>
-                  <a:srgbClr val="1A1A1A"/>
-                </a:solidFill>
-                <a:latin typeface="Consolas"/>
-              </a:rPr>
-              <a:t>                    hashlib.sha256).hexdigest().upper()</a:t>
-            </a:r>
-          </a:p>
-          <a:p>
-            <a:pPr>
-              <a:spcAft>
-                <a:spcPts val="0"/>
-              </a:spcAft>
-            </a:pPr>
-            <a:r>
-              <a:rPr sz="1100" b="0" i="0">
-                <a:solidFill>
-                  <a:srgbClr val="1A1A1A"/>
-                </a:solidFill>
-                <a:latin typeface="Consolas"/>
-              </a:rPr>
-              <a:t>    headers = {"X-CC-APIKEY": api_key, "sign": sign,</a:t>
-            </a:r>
-          </a:p>
-          <a:p>
-            <a:pPr>
-              <a:spcAft>
-                <a:spcPts val="0"/>
-              </a:spcAft>
-            </a:pPr>
-            <a:r>
-              <a:rPr sz="1100" b="0" i="0">
-                <a:solidFill>
-                  <a:srgbClr val="1A1A1A"/>
-                </a:solidFill>
-                <a:latin typeface="Consolas"/>
-              </a:rPr>
-              <a:t>               "ts": ts, "X-REQ-TS-DIFF": window}</a:t>
-            </a:r>
-          </a:p>
-          <a:p>
-            <a:pPr>
-              <a:spcAft>
-                <a:spcPts val="0"/>
-              </a:spcAft>
-            </a:pPr>
-            <a:r>
-              <a:rPr sz="1100" b="0" i="0">
-                <a:solidFill>
-                  <a:srgbClr val="1A1A1A"/>
-                </a:solidFill>
-                <a:latin typeface="Consolas"/>
-              </a:rPr>
-              <a:t>    r = requests.get(BASE + path, params=params, headers=headers, timeout=10)</a:t>
-            </a:r>
-          </a:p>
-          <a:p>
-            <a:pPr>
-              <a:spcAft>
-                <a:spcPts val="0"/>
-              </a:spcAft>
-            </a:pPr>
-            <a:r>
-              <a:rPr sz="1100" b="0" i="0">
-                <a:solidFill>
-                  <a:srgbClr val="1A1A1A"/>
-                </a:solidFill>
-                <a:latin typeface="Consolas"/>
-              </a:rPr>
-              <a:t>    r.raise_for_status()</a:t>
-            </a:r>
-          </a:p>
-          <a:p>
-            <a:pPr>
-              <a:spcAft>
-                <a:spcPts val="0"/>
-              </a:spcAft>
-            </a:pPr>
-            <a:r>
-              <a:rPr sz="1100" b="0" i="0">
-                <a:solidFill>
-                  <a:srgbClr val="1A1A1A"/>
-                </a:solidFill>
-                <a:latin typeface="Consolas"/>
-              </a:rPr>
-              <a:t>    return r.json()</a:t>
-            </a:r>
-          </a:p>
-          <a:p>
-            <a:pPr>
-              <a:spcAft>
-                <a:spcPts val="0"/>
-              </a:spcAft>
-            </a:pPr>
-            <a:r>
-              <a:rPr sz="1100" b="0" i="0">
-                <a:solidFill>
-                  <a:srgbClr val="1A1A1A"/>
-                </a:solidFill>
-                <a:latin typeface="Consolas"/>
-              </a:rPr>
-              <a:t> </a:t>
-            </a:r>
-          </a:p>
-          <a:p>
-            <a:pPr>
-              <a:spcAft>
-                <a:spcPts val="0"/>
-              </a:spcAft>
-            </a:pPr>
-            <a:r>
-              <a:rPr sz="1100" b="0" i="0">
-                <a:solidFill>
-                  <a:srgbClr val="1A1A1A"/>
-                </a:solidFill>
-                <a:latin typeface="Consolas"/>
-              </a:rPr>
-              <a:t># Example: list all BTC option instruments</a:t>
-            </a:r>
-          </a:p>
-          <a:p>
-            <a:pPr>
-              <a:spcAft>
-                <a:spcPts val="0"/>
-              </a:spcAft>
-            </a:pPr>
-            <a:r>
-              <a:rPr sz="1100" b="0" i="0">
-                <a:solidFill>
-                  <a:srgbClr val="1A1A1A"/>
-                </a:solidFill>
-                <a:latin typeface="Consolas"/>
-              </a:rPr>
-              <a:t>print(signed_get("/open/option/getInstruments/BTC"))</a:t>
-            </a:r>
-          </a:p>
-        </p:txBody>
-      </p:sp>
-    </p:spTree>
-  </p:cSld>
-  <p:clrMapOvr>
-    <a:masterClrMapping/>
-  </p:clrMapOvr>
-</p:sld>
-</file>
-
-<file path=ppt/slides/slide12.xml><?xml version="1.0" encoding="utf-8"?>
 <p:sld xmlns:a="http://schemas.openxmlformats.org/drawingml/2006/main" xmlns:p="http://schemas.openxmlformats.org/presentationml/2006/main" xmlns:r="http://schemas.openxmlformats.org/officeDocument/2006/relationships">
   <p:cSld>
     <p:spTree>
@@ -4145,7 +3407,7 @@
           <a:noFill/>
         </p:spPr>
         <p:txBody>
-          <a:bodyPr wrap="none">
+          <a:bodyPr wrap="square">
             <a:spAutoFit/>
           </a:bodyPr>
           <a:lstStyle/>
@@ -4157,7 +3419,18 @@
                 </a:solidFill>
                 <a:latin typeface="Arial"/>
               </a:rPr>
-              <a:t>Glossary — Key Terms</a:t>
+              <a:t>Getting the Data from Coincall</a:t>
+            </a:r>
+          </a:p>
+          <a:p>
+            <a:r>
+              <a:rPr sz="1300" b="0" i="1">
+                <a:solidFill>
+                  <a:srgbClr val="6D6D6D"/>
+                </a:solidFill>
+                <a:latin typeface="Arial"/>
+              </a:rPr>
+              <a:t>Cross-check exact paths at https://docs.coincall.com/</a:t>
             </a:r>
           </a:p>
         </p:txBody>
@@ -4229,176 +3502,687 @@
           <a:p>
             <a:pPr>
               <a:spcAft>
-                <a:spcPts val="700"/>
-              </a:spcAft>
-            </a:pPr>
-            <a:r>
-              <a:rPr sz="1500" b="1" i="0">
-                <a:solidFill>
-                  <a:srgbClr val="CC0000"/>
-                </a:solidFill>
-                <a:latin typeface="Arial"/>
-              </a:rPr>
-              <a:t>Market maker — </a:t>
-            </a:r>
-            <a:r>
-              <a:rPr sz="1500" b="0" i="0">
-                <a:solidFill>
-                  <a:srgbClr val="1A1A1A"/>
-                </a:solidFill>
-                <a:latin typeface="Arial"/>
-              </a:rPr>
-              <a:t>liquidity provider that continuously quotes bid and ask, earning the spread</a:t>
-            </a:r>
-          </a:p>
-          <a:p>
-            <a:pPr>
-              <a:spcAft>
-                <a:spcPts val="700"/>
-              </a:spcAft>
-            </a:pPr>
-            <a:r>
-              <a:rPr sz="1500" b="1" i="0">
-                <a:solidFill>
-                  <a:srgbClr val="CC0000"/>
-                </a:solidFill>
-                <a:latin typeface="Arial"/>
-              </a:rPr>
-              <a:t>Taker — </a:t>
-            </a:r>
-            <a:r>
-              <a:rPr sz="1500" b="0" i="0">
-                <a:solidFill>
-                  <a:srgbClr val="1A1A1A"/>
-                </a:solidFill>
-                <a:latin typeface="Arial"/>
-              </a:rPr>
-              <a:t>participant that crosses the spread for immediate execution</a:t>
-            </a:r>
-          </a:p>
-          <a:p>
-            <a:pPr>
-              <a:spcAft>
-                <a:spcPts val="700"/>
-              </a:spcAft>
-            </a:pPr>
-            <a:r>
-              <a:rPr sz="1500" b="1" i="0">
-                <a:solidFill>
-                  <a:srgbClr val="CC0000"/>
-                </a:solidFill>
-                <a:latin typeface="Arial"/>
-              </a:rPr>
-              <a:t>Bid-ask spread — </a:t>
-            </a:r>
-            <a:r>
-              <a:rPr sz="1500" b="0" i="0">
-                <a:solidFill>
-                  <a:srgbClr val="1A1A1A"/>
-                </a:solidFill>
-                <a:latin typeface="Arial"/>
-              </a:rPr>
-              <a:t>best ask minus best bid; the maker's revenue and risk premium</a:t>
-            </a:r>
-          </a:p>
-          <a:p>
-            <a:pPr>
-              <a:spcAft>
-                <a:spcPts val="700"/>
-              </a:spcAft>
-            </a:pPr>
-            <a:r>
-              <a:rPr sz="1500" b="1" i="0">
-                <a:solidFill>
-                  <a:srgbClr val="CC0000"/>
-                </a:solidFill>
-                <a:latin typeface="Arial"/>
-              </a:rPr>
-              <a:t>Inventory — </a:t>
-            </a:r>
-            <a:r>
-              <a:rPr sz="1500" b="0" i="0">
-                <a:solidFill>
-                  <a:srgbClr val="1A1A1A"/>
-                </a:solidFill>
-                <a:latin typeface="Arial"/>
-              </a:rPr>
-              <a:t>the maker's net position; the main source of risk</a:t>
-            </a:r>
-          </a:p>
-          <a:p>
-            <a:pPr>
-              <a:spcAft>
-                <a:spcPts val="700"/>
-              </a:spcAft>
-            </a:pPr>
-            <a:r>
-              <a:rPr sz="1500" b="1" i="0">
-                <a:solidFill>
-                  <a:srgbClr val="CC0000"/>
-                </a:solidFill>
-                <a:latin typeface="Arial"/>
-              </a:rPr>
-              <a:t>Milestone — </a:t>
-            </a:r>
-            <a:r>
-              <a:rPr sz="1500" b="0" i="0">
-                <a:solidFill>
-                  <a:srgbClr val="1A1A1A"/>
-                </a:solidFill>
-                <a:latin typeface="Arial"/>
-              </a:rPr>
-              <a:t>graded software deliverable, due in Weeks 5, 7, and 9</a:t>
-            </a:r>
-          </a:p>
-          <a:p>
-            <a:pPr>
-              <a:spcAft>
-                <a:spcPts val="700"/>
-              </a:spcAft>
-            </a:pPr>
-            <a:r>
-              <a:rPr sz="1500" b="1" i="0">
-                <a:solidFill>
-                  <a:srgbClr val="CC0000"/>
-                </a:solidFill>
-                <a:latin typeface="Arial"/>
-              </a:rPr>
-              <a:t>PyTorch / autograd — </a:t>
-            </a:r>
-            <a:r>
-              <a:rPr sz="1500" b="0" i="0">
-                <a:solidFill>
-                  <a:srgbClr val="1A1A1A"/>
-                </a:solidFill>
-                <a:latin typeface="Arial"/>
-              </a:rPr>
-              <a:t>Python ML library; automatic differentiation computes Greeks for you</a:t>
-            </a:r>
-          </a:p>
-          <a:p>
-            <a:pPr>
-              <a:spcAft>
-                <a:spcPts val="700"/>
-              </a:spcAft>
-            </a:pPr>
-            <a:r>
-              <a:rPr sz="1500" b="1" i="0">
-                <a:solidFill>
-                  <a:srgbClr val="CC0000"/>
-                </a:solidFill>
-                <a:latin typeface="Arial"/>
-              </a:rPr>
-              <a:t>pybind11 — </a:t>
-            </a:r>
-            <a:r>
-              <a:rPr sz="1500" b="0" i="0">
-                <a:solidFill>
-                  <a:srgbClr val="1A1A1A"/>
-                </a:solidFill>
-                <a:latin typeface="Arial"/>
-              </a:rPr>
-              <a:t>library that exposes C++ functions to Python (used in Week 7)</a:t>
+                <a:spcPts val="500"/>
+              </a:spcAft>
+            </a:pPr>
+            <a:r>
+              <a:rPr sz="1200" b="0" i="0">
+                <a:solidFill>
+                  <a:srgbClr val="1A1A1A"/>
+                </a:solidFill>
+                <a:latin typeface="Arial"/>
+              </a:rPr>
+              <a:t>•  Base URL: https://api.coincall.com   |   Python SDK: github.com/CoincallExchange</a:t>
+            </a:r>
+          </a:p>
+          <a:p>
+            <a:pPr>
+              <a:spcAft>
+                <a:spcPts val="500"/>
+              </a:spcAft>
+            </a:pPr>
+            <a:r>
+              <a:rPr sz="1200" b="0" i="0">
+                <a:solidFill>
+                  <a:srgbClr val="1A1A1A"/>
+                </a:solidFill>
+                <a:latin typeface="Arial"/>
+              </a:rPr>
+              <a:t>•  Signed request headers: X-CC-APIKEY, sign (HMAC-SHA256, upper hex), ts (ms), X-REQ-TS-DIFF</a:t>
+            </a:r>
+          </a:p>
+          <a:p>
+            <a:pPr>
+              <a:spcAft>
+                <a:spcPts val="500"/>
+              </a:spcAft>
+            </a:pPr>
+            <a:r>
+              <a:rPr sz="1200" b="0" i="0">
+                <a:solidFill>
+                  <a:srgbClr val="1A1A1A"/>
+                </a:solidFill>
+                <a:latin typeface="Arial"/>
+              </a:rPr>
+              <a:t>•  Signing: sort params alphabetically, append uuid, ts, x-req-ts-diff, HMAC-SHA256 with secret</a:t>
+            </a:r>
+          </a:p>
+          <a:p>
+            <a:pPr>
+              <a:spcAft>
+                <a:spcPts val="500"/>
+              </a:spcAft>
+            </a:pPr>
+            <a:r>
+              <a:rPr sz="1200" b="0" i="0">
+                <a:solidFill>
+                  <a:srgbClr val="1A1A1A"/>
+                </a:solidFill>
+                <a:latin typeface="Arial"/>
+              </a:rPr>
+              <a:t>•  Rate limits (per docs): orderbook 30/2s per user; public config 10/2s per IP</a:t>
+            </a:r>
+          </a:p>
+          <a:p>
+            <a:pPr>
+              <a:spcAft>
+                <a:spcPts val="500"/>
+              </a:spcAft>
+            </a:pPr>
+            <a:r>
+              <a:rPr sz="1200" b="0" i="0">
+                <a:solidFill>
+                  <a:srgbClr val="1A1A1A"/>
+                </a:solidFill>
+                <a:latin typeface="Arial"/>
+              </a:rPr>
+              <a:t>•  Key endpoints you will use across the program:</a:t>
+            </a:r>
+          </a:p>
+          <a:p>
+            <a:pPr>
+              <a:spcAft>
+                <a:spcPts val="500"/>
+              </a:spcAft>
+            </a:pPr>
+            <a:r>
+              <a:rPr sz="1200" b="0" i="0">
+                <a:solidFill>
+                  <a:srgbClr val="1A1A1A"/>
+                </a:solidFill>
+                <a:latin typeface="Consolas"/>
+              </a:rPr>
+              <a:t>    Instruments:   GET /open/option/getInstruments/{baseCurrency}</a:t>
+            </a:r>
+          </a:p>
+          <a:p>
+            <a:pPr>
+              <a:spcAft>
+                <a:spcPts val="500"/>
+              </a:spcAft>
+            </a:pPr>
+            <a:r>
+              <a:rPr sz="1200" b="0" i="0">
+                <a:solidFill>
+                  <a:srgbClr val="1A1A1A"/>
+                </a:solidFill>
+                <a:latin typeface="Consolas"/>
+              </a:rPr>
+              <a:t>    Option chain:  GET /open/option/get/v1/{index}</a:t>
+            </a:r>
+          </a:p>
+          <a:p>
+            <a:pPr>
+              <a:spcAft>
+                <a:spcPts val="500"/>
+              </a:spcAft>
+            </a:pPr>
+            <a:r>
+              <a:rPr sz="1200" b="0" i="0">
+                <a:solidFill>
+                  <a:srgbClr val="1A1A1A"/>
+                </a:solidFill>
+                <a:latin typeface="Consolas"/>
+              </a:rPr>
+              <a:t>    Option book:   GET /open/option/order/orderbook/v1/{symbol}  (100 depth)</a:t>
+            </a:r>
+          </a:p>
+          <a:p>
+            <a:pPr>
+              <a:spcAft>
+                <a:spcPts val="500"/>
+              </a:spcAft>
+            </a:pPr>
+            <a:r>
+              <a:rPr sz="1200" b="0" i="0">
+                <a:solidFill>
+                  <a:srgbClr val="1A1A1A"/>
+                </a:solidFill>
+                <a:latin typeface="Consolas"/>
+              </a:rPr>
+              <a:t>    Option detail: GET /open/option/detail/v1/{symbol}  (mark, IV, delta/gamma/vega/theta)</a:t>
+            </a:r>
+          </a:p>
+          <a:p>
+            <a:pPr>
+              <a:spcAft>
+                <a:spcPts val="500"/>
+              </a:spcAft>
+            </a:pPr>
+            <a:r>
+              <a:rPr sz="1200" b="0" i="0">
+                <a:solidFill>
+                  <a:srgbClr val="1A1A1A"/>
+                </a:solidFill>
+                <a:latin typeface="Consolas"/>
+              </a:rPr>
+              <a:t>    Trades:        GET /open/option/trade/lasttrade/v1/{symbol}</a:t>
+            </a:r>
+          </a:p>
+          <a:p>
+            <a:pPr>
+              <a:spcAft>
+                <a:spcPts val="500"/>
+              </a:spcAft>
+            </a:pPr>
+            <a:r>
+              <a:rPr sz="1200" b="0" i="0">
+                <a:solidFill>
+                  <a:srgbClr val="1A1A1A"/>
+                </a:solidFill>
+                <a:latin typeface="Consolas"/>
+              </a:rPr>
+              <a:t>    Futures book:  GET /open/futures/order/orderbook/v1/{symbol}</a:t>
+            </a:r>
+          </a:p>
+          <a:p>
+            <a:pPr>
+              <a:spcAft>
+                <a:spcPts val="500"/>
+              </a:spcAft>
+            </a:pPr>
+            <a:r>
+              <a:rPr sz="1200" b="0" i="0">
+                <a:solidFill>
+                  <a:srgbClr val="1A1A1A"/>
+                </a:solidFill>
+                <a:latin typeface="Consolas"/>
+              </a:rPr>
+              <a:t>    Funding:       GET /open/public/fundingRate/v1?symbol=BTCUSD</a:t>
+            </a:r>
+          </a:p>
+          <a:p>
+            <a:pPr>
+              <a:spcAft>
+                <a:spcPts val="500"/>
+              </a:spcAft>
+            </a:pPr>
+            <a:r>
+              <a:rPr sz="1200" b="0" i="0">
+                <a:solidFill>
+                  <a:srgbClr val="1A1A1A"/>
+                </a:solidFill>
+                <a:latin typeface="Consolas"/>
+              </a:rPr>
+              <a:t>    Klines:        GET /open/option/market/kline/history/v1/{optionName}?period=h1</a:t>
+            </a:r>
+          </a:p>
+          <a:p>
+            <a:pPr>
+              <a:spcAft>
+                <a:spcPts val="500"/>
+              </a:spcAft>
+            </a:pPr>
+            <a:r>
+              <a:rPr sz="1200" b="0" i="0">
+                <a:solidFill>
+                  <a:srgbClr val="1A1A1A"/>
+                </a:solidFill>
+                <a:latin typeface="Arial"/>
+              </a:rPr>
+              <a:t>•  WebSocket channels: /options/pricing, /options/orderbook, /options/lasttrade, /options/kline</a:t>
+            </a:r>
+          </a:p>
+          <a:p>
+            <a:pPr>
+              <a:spcAft>
+                <a:spcPts val="500"/>
+              </a:spcAft>
+            </a:pPr>
+            <a:r>
+              <a:rPr sz="1200" b="0" i="0">
+                <a:solidFill>
+                  <a:srgbClr val="1A1A1A"/>
+                </a:solidFill>
+                <a:latin typeface="Arial"/>
+              </a:rPr>
+              <a:t>•  ALWAYS verify the exact path/params against https://docs.coincall.com/ -- the API evolves.</a:t>
+            </a:r>
+          </a:p>
+        </p:txBody>
+      </p:sp>
+    </p:spTree>
+  </p:cSld>
+  <p:clrMapOvr>
+    <a:masterClrMapping/>
+  </p:clrMapOvr>
+</p:sld>
+</file>
+
+<file path=ppt/slides/slide12.xml><?xml version="1.0" encoding="utf-8"?>
+<p:sld xmlns:a="http://schemas.openxmlformats.org/drawingml/2006/main" xmlns:p="http://schemas.openxmlformats.org/presentationml/2006/main" xmlns:r="http://schemas.openxmlformats.org/officeDocument/2006/relationships">
+  <p:cSld>
+    <p:spTree>
+      <p:nvGrpSpPr>
+        <p:cNvPr id="1" name=""/>
+        <p:cNvGrpSpPr/>
+        <p:nvPr/>
+      </p:nvGrpSpPr>
+      <p:grpSpPr/>
+      <p:sp>
+        <p:nvSpPr>
+          <p:cNvPr id="2" name="TextBox 1"/>
+          <p:cNvSpPr txBox="1"/>
+          <p:nvPr/>
+        </p:nvSpPr>
+        <p:spPr>
+          <a:xfrm>
+            <a:off x="457200" y="365760"/>
+            <a:ext cx="11247120" cy="640080"/>
+          </a:xfrm>
+          <a:prstGeom prst="rect">
+            <a:avLst/>
+          </a:prstGeom>
+          <a:noFill/>
+        </p:spPr>
+        <p:txBody>
+          <a:bodyPr wrap="none">
+            <a:spAutoFit/>
+          </a:bodyPr>
+          <a:lstStyle/>
+          <a:p>
+            <a:r>
+              <a:rPr sz="1800" b="1" i="0">
+                <a:solidFill>
+                  <a:srgbClr val="990000"/>
+                </a:solidFill>
+                <a:latin typeface="Arial"/>
+              </a:rPr>
+              <a:t>Code — coincall_client.py -- signed REST helper (verify signing vs. live docs)</a:t>
+            </a:r>
+          </a:p>
+        </p:txBody>
+      </p:sp>
+      <p:sp>
+        <p:nvSpPr>
+          <p:cNvPr id="3" name="Rectangle 2"/>
+          <p:cNvSpPr/>
+          <p:nvPr/>
+        </p:nvSpPr>
+        <p:spPr>
+          <a:xfrm>
+            <a:off x="457200" y="1097280"/>
+            <a:ext cx="11247120" cy="5394960"/>
+          </a:xfrm>
+          <a:prstGeom prst="rect">
+            <a:avLst/>
+          </a:prstGeom>
+          <a:solidFill>
+            <a:srgbClr val="F5F5F5"/>
+          </a:solidFill>
+          <a:ln w="9525">
+            <a:solidFill>
+              <a:srgbClr val="6D6D6D"/>
+            </a:solidFill>
+          </a:ln>
+        </p:spPr>
+        <p:style>
+          <a:lnRef idx="1">
+            <a:schemeClr val="accent1"/>
+          </a:lnRef>
+          <a:fillRef idx="3">
+            <a:schemeClr val="accent1"/>
+          </a:fillRef>
+          <a:effectRef idx="2">
+            <a:schemeClr val="accent1"/>
+          </a:effectRef>
+          <a:fontRef idx="minor">
+            <a:schemeClr val="lt1"/>
+          </a:fontRef>
+        </p:style>
+        <p:txBody>
+          <a:bodyPr rtlCol="0" anchor="ctr" wrap="square" lIns="182880" tIns="91440"/>
+          <a:lstStyle/>
+          <a:p>
+            <a:pPr algn="ctr">
+              <a:spcAft>
+                <a:spcPts val="0"/>
+              </a:spcAft>
+            </a:pPr>
+            <a:r>
+              <a:rPr sz="1100" b="0" i="0">
+                <a:solidFill>
+                  <a:srgbClr val="1A1A1A"/>
+                </a:solidFill>
+                <a:latin typeface="Consolas"/>
+              </a:rPr>
+              <a:t>import time, hmac, hashlib, uuid, requests</a:t>
+            </a:r>
+          </a:p>
+          <a:p>
+            <a:pPr>
+              <a:spcAft>
+                <a:spcPts val="0"/>
+              </a:spcAft>
+            </a:pPr>
+            <a:r>
+              <a:rPr sz="1100" b="0" i="0">
+                <a:solidFill>
+                  <a:srgbClr val="1A1A1A"/>
+                </a:solidFill>
+                <a:latin typeface="Consolas"/>
+              </a:rPr>
+              <a:t> </a:t>
+            </a:r>
+          </a:p>
+          <a:p>
+            <a:pPr>
+              <a:spcAft>
+                <a:spcPts val="0"/>
+              </a:spcAft>
+            </a:pPr>
+            <a:r>
+              <a:rPr sz="1100" b="0" i="0">
+                <a:solidFill>
+                  <a:srgbClr val="1A1A1A"/>
+                </a:solidFill>
+                <a:latin typeface="Consolas"/>
+              </a:rPr>
+              <a:t>BASE = "https://api.coincall.com"</a:t>
+            </a:r>
+          </a:p>
+          <a:p>
+            <a:pPr>
+              <a:spcAft>
+                <a:spcPts val="0"/>
+              </a:spcAft>
+            </a:pPr>
+            <a:r>
+              <a:rPr sz="1100" b="0" i="0">
+                <a:solidFill>
+                  <a:srgbClr val="1A1A1A"/>
+                </a:solidFill>
+                <a:latin typeface="Consolas"/>
+              </a:rPr>
+              <a:t> </a:t>
+            </a:r>
+          </a:p>
+          <a:p>
+            <a:pPr>
+              <a:spcAft>
+                <a:spcPts val="0"/>
+              </a:spcAft>
+            </a:pPr>
+            <a:r>
+              <a:rPr sz="1100" b="0" i="0">
+                <a:solidFill>
+                  <a:srgbClr val="1A1A1A"/>
+                </a:solidFill>
+                <a:latin typeface="Consolas"/>
+              </a:rPr>
+              <a:t>def signed_get(path, params=None, api_key="", api_secret=""):</a:t>
+            </a:r>
+          </a:p>
+          <a:p>
+            <a:pPr>
+              <a:spcAft>
+                <a:spcPts val="0"/>
+              </a:spcAft>
+            </a:pPr>
+            <a:r>
+              <a:rPr sz="1100" b="0" i="0">
+                <a:solidFill>
+                  <a:srgbClr val="1A1A1A"/>
+                </a:solidFill>
+                <a:latin typeface="Consolas"/>
+              </a:rPr>
+              <a:t>    """Minimal Coincall signed GET. Public market-data endpoints often work</a:t>
+            </a:r>
+          </a:p>
+          <a:p>
+            <a:pPr>
+              <a:spcAft>
+                <a:spcPts val="0"/>
+              </a:spcAft>
+            </a:pPr>
+            <a:r>
+              <a:rPr sz="1100" b="0" i="0">
+                <a:solidFill>
+                  <a:srgbClr val="1A1A1A"/>
+                </a:solidFill>
+                <a:latin typeface="Consolas"/>
+              </a:rPr>
+              <a:t>    unsigned; this shows the signed pattern used for account endpoints."""</a:t>
+            </a:r>
+          </a:p>
+          <a:p>
+            <a:pPr>
+              <a:spcAft>
+                <a:spcPts val="0"/>
+              </a:spcAft>
+            </a:pPr>
+            <a:r>
+              <a:rPr sz="1100" b="0" i="0">
+                <a:solidFill>
+                  <a:srgbClr val="1A1A1A"/>
+                </a:solidFill>
+                <a:latin typeface="Consolas"/>
+              </a:rPr>
+              <a:t>    params = params or {}</a:t>
+            </a:r>
+          </a:p>
+          <a:p>
+            <a:pPr>
+              <a:spcAft>
+                <a:spcPts val="0"/>
+              </a:spcAft>
+            </a:pPr>
+            <a:r>
+              <a:rPr sz="1100" b="0" i="0">
+                <a:solidFill>
+                  <a:srgbClr val="1A1A1A"/>
+                </a:solidFill>
+                <a:latin typeface="Consolas"/>
+              </a:rPr>
+              <a:t>    ts, window = str(int(time.time() * 1000)), "5000"</a:t>
+            </a:r>
+          </a:p>
+          <a:p>
+            <a:pPr>
+              <a:spcAft>
+                <a:spcPts val="0"/>
+              </a:spcAft>
+            </a:pPr>
+            <a:r>
+              <a:rPr sz="1100" b="0" i="0">
+                <a:solidFill>
+                  <a:srgbClr val="1A1A1A"/>
+                </a:solidFill>
+                <a:latin typeface="Consolas"/>
+              </a:rPr>
+              <a:t>    items = sorted(params.items())                       # sort alphabetically</a:t>
+            </a:r>
+          </a:p>
+          <a:p>
+            <a:pPr>
+              <a:spcAft>
+                <a:spcPts val="0"/>
+              </a:spcAft>
+            </a:pPr>
+            <a:r>
+              <a:rPr sz="1100" b="0" i="0">
+                <a:solidFill>
+                  <a:srgbClr val="1A1A1A"/>
+                </a:solidFill>
+                <a:latin typeface="Consolas"/>
+              </a:rPr>
+              <a:t>    payload = "&amp;".join(f"{k}={v}" for k, v in items)</a:t>
+            </a:r>
+          </a:p>
+          <a:p>
+            <a:pPr>
+              <a:spcAft>
+                <a:spcPts val="0"/>
+              </a:spcAft>
+            </a:pPr>
+            <a:r>
+              <a:rPr sz="1100" b="0" i="0">
+                <a:solidFill>
+                  <a:srgbClr val="1A1A1A"/>
+                </a:solidFill>
+                <a:latin typeface="Consolas"/>
+              </a:rPr>
+              <a:t>    payload += f"&amp;uuid={uuid.uuid4().hex}&amp;ts={ts}&amp;x-req-ts-diff={window}"</a:t>
+            </a:r>
+          </a:p>
+          <a:p>
+            <a:pPr>
+              <a:spcAft>
+                <a:spcPts val="0"/>
+              </a:spcAft>
+            </a:pPr>
+            <a:r>
+              <a:rPr sz="1100" b="0" i="0">
+                <a:solidFill>
+                  <a:srgbClr val="1A1A1A"/>
+                </a:solidFill>
+                <a:latin typeface="Consolas"/>
+              </a:rPr>
+              <a:t>    sign = hmac.new(api_secret.encode(), payload.encode(),</a:t>
+            </a:r>
+          </a:p>
+          <a:p>
+            <a:pPr>
+              <a:spcAft>
+                <a:spcPts val="0"/>
+              </a:spcAft>
+            </a:pPr>
+            <a:r>
+              <a:rPr sz="1100" b="0" i="0">
+                <a:solidFill>
+                  <a:srgbClr val="1A1A1A"/>
+                </a:solidFill>
+                <a:latin typeface="Consolas"/>
+              </a:rPr>
+              <a:t>                    hashlib.sha256).hexdigest().upper()</a:t>
+            </a:r>
+          </a:p>
+          <a:p>
+            <a:pPr>
+              <a:spcAft>
+                <a:spcPts val="0"/>
+              </a:spcAft>
+            </a:pPr>
+            <a:r>
+              <a:rPr sz="1100" b="0" i="0">
+                <a:solidFill>
+                  <a:srgbClr val="1A1A1A"/>
+                </a:solidFill>
+                <a:latin typeface="Consolas"/>
+              </a:rPr>
+              <a:t>    headers = {"X-CC-APIKEY": api_key, "sign": sign,</a:t>
+            </a:r>
+          </a:p>
+          <a:p>
+            <a:pPr>
+              <a:spcAft>
+                <a:spcPts val="0"/>
+              </a:spcAft>
+            </a:pPr>
+            <a:r>
+              <a:rPr sz="1100" b="0" i="0">
+                <a:solidFill>
+                  <a:srgbClr val="1A1A1A"/>
+                </a:solidFill>
+                <a:latin typeface="Consolas"/>
+              </a:rPr>
+              <a:t>               "ts": ts, "X-REQ-TS-DIFF": window}</a:t>
+            </a:r>
+          </a:p>
+          <a:p>
+            <a:pPr>
+              <a:spcAft>
+                <a:spcPts val="0"/>
+              </a:spcAft>
+            </a:pPr>
+            <a:r>
+              <a:rPr sz="1100" b="0" i="0">
+                <a:solidFill>
+                  <a:srgbClr val="1A1A1A"/>
+                </a:solidFill>
+                <a:latin typeface="Consolas"/>
+              </a:rPr>
+              <a:t>    r = requests.get(BASE + path, params=params, headers=headers, timeout=10)</a:t>
+            </a:r>
+          </a:p>
+          <a:p>
+            <a:pPr>
+              <a:spcAft>
+                <a:spcPts val="0"/>
+              </a:spcAft>
+            </a:pPr>
+            <a:r>
+              <a:rPr sz="1100" b="0" i="0">
+                <a:solidFill>
+                  <a:srgbClr val="1A1A1A"/>
+                </a:solidFill>
+                <a:latin typeface="Consolas"/>
+              </a:rPr>
+              <a:t>    r.raise_for_status()</a:t>
+            </a:r>
+          </a:p>
+          <a:p>
+            <a:pPr>
+              <a:spcAft>
+                <a:spcPts val="0"/>
+              </a:spcAft>
+            </a:pPr>
+            <a:r>
+              <a:rPr sz="1100" b="0" i="0">
+                <a:solidFill>
+                  <a:srgbClr val="1A1A1A"/>
+                </a:solidFill>
+                <a:latin typeface="Consolas"/>
+              </a:rPr>
+              <a:t>    return r.json()</a:t>
+            </a:r>
+          </a:p>
+          <a:p>
+            <a:pPr>
+              <a:spcAft>
+                <a:spcPts val="0"/>
+              </a:spcAft>
+            </a:pPr>
+            <a:r>
+              <a:rPr sz="1100" b="0" i="0">
+                <a:solidFill>
+                  <a:srgbClr val="1A1A1A"/>
+                </a:solidFill>
+                <a:latin typeface="Consolas"/>
+              </a:rPr>
+              <a:t> </a:t>
+            </a:r>
+          </a:p>
+          <a:p>
+            <a:pPr>
+              <a:spcAft>
+                <a:spcPts val="0"/>
+              </a:spcAft>
+            </a:pPr>
+            <a:r>
+              <a:rPr sz="1100" b="0" i="0">
+                <a:solidFill>
+                  <a:srgbClr val="1A1A1A"/>
+                </a:solidFill>
+                <a:latin typeface="Consolas"/>
+              </a:rPr>
+              <a:t># Example: list all BTC option instruments</a:t>
+            </a:r>
+          </a:p>
+          <a:p>
+            <a:pPr>
+              <a:spcAft>
+                <a:spcPts val="0"/>
+              </a:spcAft>
+            </a:pPr>
+            <a:r>
+              <a:rPr sz="1100" b="0" i="0">
+                <a:solidFill>
+                  <a:srgbClr val="1A1A1A"/>
+                </a:solidFill>
+                <a:latin typeface="Consolas"/>
+              </a:rPr>
+              <a:t>print(signed_get("/open/option/getInstruments/BTC"))</a:t>
             </a:r>
           </a:p>
         </p:txBody>
@@ -4462,7 +4246,7 @@
           <a:noFill/>
         </p:spPr>
         <p:txBody>
-          <a:bodyPr wrap="square">
+          <a:bodyPr wrap="none">
             <a:spAutoFit/>
           </a:bodyPr>
           <a:lstStyle/>
@@ -4474,7 +4258,7 @@
                 </a:solidFill>
                 <a:latin typeface="Arial"/>
               </a:rPr>
-              <a:t>Reading</a:t>
+              <a:t>Glossary — Key Terms</a:t>
             </a:r>
           </a:p>
         </p:txBody>
@@ -4546,33 +4330,176 @@
           <a:p>
             <a:pPr>
               <a:spcAft>
-                <a:spcPts val="800"/>
-              </a:spcAft>
-            </a:pPr>
-            <a:r>
-              <a:rPr sz="1700" b="0" i="0">
-                <a:solidFill>
-                  <a:srgbClr val="1A1A1A"/>
-                </a:solidFill>
-                <a:latin typeface="Arial"/>
-              </a:rPr>
-              <a:t>•  Cartea-Jaikumar-Penalva, Ch. 1; Avellaneda-Stoikov (2008) -- skim</a:t>
-            </a:r>
-          </a:p>
-          <a:p>
-            <a:pPr>
-              <a:spcAft>
-                <a:spcPts val="800"/>
-              </a:spcAft>
-            </a:pPr>
-            <a:r>
-              <a:rPr sz="1700" b="0" i="0">
-                <a:solidFill>
-                  <a:srgbClr val="1A1A1A"/>
-                </a:solidFill>
-                <a:latin typeface="Arial"/>
-              </a:rPr>
-              <a:t>•  Coincall API docs: https://docs.coincall.com/  (read 'Getting Started')</a:t>
+                <a:spcPts val="700"/>
+              </a:spcAft>
+            </a:pPr>
+            <a:r>
+              <a:rPr sz="1500" b="1" i="0">
+                <a:solidFill>
+                  <a:srgbClr val="CC0000"/>
+                </a:solidFill>
+                <a:latin typeface="Arial"/>
+              </a:rPr>
+              <a:t>Market maker — </a:t>
+            </a:r>
+            <a:r>
+              <a:rPr sz="1500" b="0" i="0">
+                <a:solidFill>
+                  <a:srgbClr val="1A1A1A"/>
+                </a:solidFill>
+                <a:latin typeface="Arial"/>
+              </a:rPr>
+              <a:t>liquidity provider that continuously quotes bid and ask, earning the spread</a:t>
+            </a:r>
+          </a:p>
+          <a:p>
+            <a:pPr>
+              <a:spcAft>
+                <a:spcPts val="700"/>
+              </a:spcAft>
+            </a:pPr>
+            <a:r>
+              <a:rPr sz="1500" b="1" i="0">
+                <a:solidFill>
+                  <a:srgbClr val="CC0000"/>
+                </a:solidFill>
+                <a:latin typeface="Arial"/>
+              </a:rPr>
+              <a:t>Taker — </a:t>
+            </a:r>
+            <a:r>
+              <a:rPr sz="1500" b="0" i="0">
+                <a:solidFill>
+                  <a:srgbClr val="1A1A1A"/>
+                </a:solidFill>
+                <a:latin typeface="Arial"/>
+              </a:rPr>
+              <a:t>participant that crosses the spread for immediate execution</a:t>
+            </a:r>
+          </a:p>
+          <a:p>
+            <a:pPr>
+              <a:spcAft>
+                <a:spcPts val="700"/>
+              </a:spcAft>
+            </a:pPr>
+            <a:r>
+              <a:rPr sz="1500" b="1" i="0">
+                <a:solidFill>
+                  <a:srgbClr val="CC0000"/>
+                </a:solidFill>
+                <a:latin typeface="Arial"/>
+              </a:rPr>
+              <a:t>Bid-ask spread — </a:t>
+            </a:r>
+            <a:r>
+              <a:rPr sz="1500" b="0" i="0">
+                <a:solidFill>
+                  <a:srgbClr val="1A1A1A"/>
+                </a:solidFill>
+                <a:latin typeface="Arial"/>
+              </a:rPr>
+              <a:t>best ask minus best bid; the maker's revenue and risk premium</a:t>
+            </a:r>
+          </a:p>
+          <a:p>
+            <a:pPr>
+              <a:spcAft>
+                <a:spcPts val="700"/>
+              </a:spcAft>
+            </a:pPr>
+            <a:r>
+              <a:rPr sz="1500" b="1" i="0">
+                <a:solidFill>
+                  <a:srgbClr val="CC0000"/>
+                </a:solidFill>
+                <a:latin typeface="Arial"/>
+              </a:rPr>
+              <a:t>Inventory — </a:t>
+            </a:r>
+            <a:r>
+              <a:rPr sz="1500" b="0" i="0">
+                <a:solidFill>
+                  <a:srgbClr val="1A1A1A"/>
+                </a:solidFill>
+                <a:latin typeface="Arial"/>
+              </a:rPr>
+              <a:t>the maker's net position; the main source of risk</a:t>
+            </a:r>
+          </a:p>
+          <a:p>
+            <a:pPr>
+              <a:spcAft>
+                <a:spcPts val="700"/>
+              </a:spcAft>
+            </a:pPr>
+            <a:r>
+              <a:rPr sz="1500" b="1" i="0">
+                <a:solidFill>
+                  <a:srgbClr val="CC0000"/>
+                </a:solidFill>
+                <a:latin typeface="Arial"/>
+              </a:rPr>
+              <a:t>Milestone — </a:t>
+            </a:r>
+            <a:r>
+              <a:rPr sz="1500" b="0" i="0">
+                <a:solidFill>
+                  <a:srgbClr val="1A1A1A"/>
+                </a:solidFill>
+                <a:latin typeface="Arial"/>
+              </a:rPr>
+              <a:t>graded software deliverable, due in Weeks 5, 7, and 9</a:t>
+            </a:r>
+          </a:p>
+          <a:p>
+            <a:pPr>
+              <a:spcAft>
+                <a:spcPts val="700"/>
+              </a:spcAft>
+            </a:pPr>
+            <a:r>
+              <a:rPr sz="1500" b="1" i="0">
+                <a:solidFill>
+                  <a:srgbClr val="CC0000"/>
+                </a:solidFill>
+                <a:latin typeface="Arial"/>
+              </a:rPr>
+              <a:t>PyTorch / autograd — </a:t>
+            </a:r>
+            <a:r>
+              <a:rPr sz="1500" b="0" i="0">
+                <a:solidFill>
+                  <a:srgbClr val="1A1A1A"/>
+                </a:solidFill>
+                <a:latin typeface="Arial"/>
+              </a:rPr>
+              <a:t>Python ML library; automatic differentiation computes Greeks for you</a:t>
+            </a:r>
+          </a:p>
+          <a:p>
+            <a:pPr>
+              <a:spcAft>
+                <a:spcPts val="700"/>
+              </a:spcAft>
+            </a:pPr>
+            <a:r>
+              <a:rPr sz="1500" b="1" i="0">
+                <a:solidFill>
+                  <a:srgbClr val="CC0000"/>
+                </a:solidFill>
+                <a:latin typeface="Arial"/>
+              </a:rPr>
+              <a:t>pybind11 — </a:t>
+            </a:r>
+            <a:r>
+              <a:rPr sz="1500" b="0" i="0">
+                <a:solidFill>
+                  <a:srgbClr val="1A1A1A"/>
+                </a:solidFill>
+                <a:latin typeface="Arial"/>
+              </a:rPr>
+              <a:t>library that exposes C++ functions to Python (used in Week 7)</a:t>
             </a:r>
           </a:p>
         </p:txBody>
@@ -4648,6 +4575,180 @@
                 </a:solidFill>
                 <a:latin typeface="Arial"/>
               </a:rPr>
+              <a:t>Reading</a:t>
+            </a:r>
+          </a:p>
+        </p:txBody>
+      </p:sp>
+      <p:sp>
+        <p:nvSpPr>
+          <p:cNvPr id="4" name="Rectangle 3"/>
+          <p:cNvSpPr/>
+          <p:nvPr/>
+        </p:nvSpPr>
+        <p:spPr>
+          <a:xfrm>
+            <a:off x="457200" y="1371600"/>
+            <a:ext cx="11247120" cy="27940"/>
+          </a:xfrm>
+          <a:prstGeom prst="rect">
+            <a:avLst/>
+          </a:prstGeom>
+          <a:solidFill>
+            <a:srgbClr val="CC0000"/>
+          </a:solidFill>
+          <a:ln>
+            <a:noFill/>
+          </a:ln>
+        </p:spPr>
+        <p:style>
+          <a:lnRef idx="1">
+            <a:schemeClr val="accent1"/>
+          </a:lnRef>
+          <a:fillRef idx="3">
+            <a:schemeClr val="accent1"/>
+          </a:fillRef>
+          <a:effectRef idx="2">
+            <a:schemeClr val="accent1"/>
+          </a:effectRef>
+          <a:fontRef idx="minor">
+            <a:schemeClr val="lt1"/>
+          </a:fontRef>
+        </p:style>
+        <p:txBody>
+          <a:bodyPr rtlCol="0" anchor="ctr"/>
+          <a:lstStyle/>
+          <a:p>
+            <a:pPr algn="ctr"/>
+          </a:p>
+        </p:txBody>
+      </p:sp>
+      <p:sp>
+        <p:nvSpPr>
+          <p:cNvPr id="5" name="TextBox 4"/>
+          <p:cNvSpPr txBox="1"/>
+          <p:nvPr/>
+        </p:nvSpPr>
+        <p:spPr>
+          <a:xfrm>
+            <a:off x="640080" y="1600200"/>
+            <a:ext cx="10972800" cy="4937760"/>
+          </a:xfrm>
+          <a:prstGeom prst="rect">
+            <a:avLst/>
+          </a:prstGeom>
+          <a:noFill/>
+        </p:spPr>
+        <p:txBody>
+          <a:bodyPr wrap="square">
+            <a:spAutoFit/>
+          </a:bodyPr>
+          <a:lstStyle/>
+          <a:p>
+            <a:pPr>
+              <a:spcAft>
+                <a:spcPts val="800"/>
+              </a:spcAft>
+            </a:pPr>
+            <a:r>
+              <a:rPr sz="1700" b="0" i="0">
+                <a:solidFill>
+                  <a:srgbClr val="1A1A1A"/>
+                </a:solidFill>
+                <a:latin typeface="Arial"/>
+              </a:rPr>
+              <a:t>•  Cartea-Jaikumar-Penalva, Ch. 1; Avellaneda-Stoikov (2008) -- skim</a:t>
+            </a:r>
+          </a:p>
+          <a:p>
+            <a:pPr>
+              <a:spcAft>
+                <a:spcPts val="800"/>
+              </a:spcAft>
+            </a:pPr>
+            <a:r>
+              <a:rPr sz="1700" b="0" i="0">
+                <a:solidFill>
+                  <a:srgbClr val="1A1A1A"/>
+                </a:solidFill>
+                <a:latin typeface="Arial"/>
+              </a:rPr>
+              <a:t>•  Coincall API docs: https://docs.coincall.com/  (read 'Getting Started')</a:t>
+            </a:r>
+          </a:p>
+        </p:txBody>
+      </p:sp>
+    </p:spTree>
+  </p:cSld>
+  <p:clrMapOvr>
+    <a:masterClrMapping/>
+  </p:clrMapOvr>
+</p:sld>
+</file>
+
+<file path=ppt/slides/slide15.xml><?xml version="1.0" encoding="utf-8"?>
+<p:sld xmlns:a="http://schemas.openxmlformats.org/drawingml/2006/main" xmlns:p="http://schemas.openxmlformats.org/presentationml/2006/main" xmlns:r="http://schemas.openxmlformats.org/officeDocument/2006/relationships">
+  <p:cSld>
+    <p:spTree>
+      <p:nvGrpSpPr>
+        <p:cNvPr id="1" name=""/>
+        <p:cNvGrpSpPr/>
+        <p:nvPr/>
+      </p:nvGrpSpPr>
+      <p:grpSpPr/>
+      <p:pic>
+        <p:nvPicPr>
+          <p:cNvPr id="2" name="Picture 1" descr="ncsu_logo.png"/>
+          <p:cNvPicPr>
+            <a:picLocks noChangeAspect="1"/>
+          </p:cNvPicPr>
+          <p:nvPr/>
+        </p:nvPicPr>
+        <p:blipFill>
+          <a:blip r:embed="rId2"/>
+          <a:stretch>
+            <a:fillRect/>
+          </a:stretch>
+        </p:blipFill>
+        <p:spPr>
+          <a:xfrm>
+            <a:off x="9784080" y="274320"/>
+            <a:ext cx="2011680" cy="316653"/>
+          </a:xfrm>
+          <a:prstGeom prst="rect">
+            <a:avLst/>
+          </a:prstGeom>
+        </p:spPr>
+      </p:pic>
+      <p:sp>
+        <p:nvSpPr>
+          <p:cNvPr id="3" name="TextBox 2"/>
+          <p:cNvSpPr txBox="1"/>
+          <p:nvPr/>
+        </p:nvSpPr>
+        <p:spPr>
+          <a:xfrm>
+            <a:off x="457200" y="457200"/>
+            <a:ext cx="8961120" cy="822960"/>
+          </a:xfrm>
+          <a:prstGeom prst="rect">
+            <a:avLst/>
+          </a:prstGeom>
+          <a:noFill/>
+        </p:spPr>
+        <p:txBody>
+          <a:bodyPr wrap="square">
+            <a:spAutoFit/>
+          </a:bodyPr>
+          <a:lstStyle/>
+          <a:p>
+            <a:r>
+              <a:rPr sz="2400" b="1" i="0">
+                <a:solidFill>
+                  <a:srgbClr val="990000"/>
+                </a:solidFill>
+                <a:latin typeface="Arial"/>
+              </a:rPr>
               <a:t>References</a:t>
             </a:r>
           </a:p>
@@ -4854,7 +4955,7 @@
                 </a:solidFill>
                 <a:latin typeface="Arial"/>
               </a:rPr>
-              <a:t>Learning Objectives</a:t>
+              <a:t>Contents</a:t>
             </a:r>
           </a:p>
         </p:txBody>
@@ -4926,65 +5027,209 @@
           <a:p>
             <a:pPr>
               <a:spcAft>
-                <a:spcPts val="800"/>
-              </a:spcAft>
-            </a:pPr>
-            <a:r>
-              <a:rPr sz="1700" b="0" i="0">
-                <a:solidFill>
-                  <a:srgbClr val="1A1A1A"/>
-                </a:solidFill>
-                <a:latin typeface="Arial"/>
-              </a:rPr>
-              <a:t>•  Understand the arc of the program and what you will build</a:t>
-            </a:r>
-          </a:p>
-          <a:p>
-            <a:pPr>
-              <a:spcAft>
-                <a:spcPts val="800"/>
-              </a:spcAft>
-            </a:pPr>
-            <a:r>
-              <a:rPr sz="1700" b="0" i="0">
-                <a:solidFill>
-                  <a:srgbClr val="1A1A1A"/>
-                </a:solidFill>
-                <a:latin typeface="Arial"/>
-              </a:rPr>
-              <a:t>•  Be clear on the timeline, the three milestones, and how you are graded</a:t>
-            </a:r>
-          </a:p>
-          <a:p>
-            <a:pPr>
-              <a:spcAft>
-                <a:spcPts val="800"/>
-              </a:spcAft>
-            </a:pPr>
-            <a:r>
-              <a:rPr sz="1700" b="0" i="0">
-                <a:solidFill>
-                  <a:srgbClr val="1A1A1A"/>
-                </a:solidFill>
-                <a:latin typeface="Arial"/>
-              </a:rPr>
-              <a:t>•  Know where the data comes from (Coincall) and how to pull it</a:t>
-            </a:r>
-          </a:p>
-          <a:p>
-            <a:pPr>
-              <a:spcAft>
-                <a:spcPts val="800"/>
-              </a:spcAft>
-            </a:pPr>
-            <a:r>
-              <a:rPr sz="1700" b="0" i="0">
-                <a:solidFill>
-                  <a:srgbClr val="1A1A1A"/>
-                </a:solidFill>
-                <a:latin typeface="Arial"/>
-              </a:rPr>
-              <a:t>•  Have the Python + PyTorch and C++/pybind11 toolchains running</a:t>
+                <a:spcPts val="500"/>
+              </a:spcAft>
+            </a:pPr>
+            <a:r>
+              <a:rPr sz="1200" b="0" i="0">
+                <a:solidFill>
+                  <a:srgbClr val="1A1A1A"/>
+                </a:solidFill>
+                <a:latin typeface="Arial"/>
+              </a:rPr>
+              <a:t>•  Learning objectives</a:t>
+            </a:r>
+          </a:p>
+          <a:p>
+            <a:pPr>
+              <a:spcAft>
+                <a:spcPts val="500"/>
+              </a:spcAft>
+            </a:pPr>
+            <a:r>
+              <a:rPr sz="1200" b="0" i="0">
+                <a:solidFill>
+                  <a:srgbClr val="1A1A1A"/>
+                </a:solidFill>
+                <a:latin typeface="Arial"/>
+              </a:rPr>
+              <a:t>•  Where We Are (Week 1 Progress Review)</a:t>
+            </a:r>
+          </a:p>
+          <a:p>
+            <a:pPr>
+              <a:spcAft>
+                <a:spcPts val="500"/>
+              </a:spcAft>
+            </a:pPr>
+            <a:r>
+              <a:rPr sz="1200" b="0" i="0">
+                <a:solidFill>
+                  <a:srgbClr val="1A1A1A"/>
+                </a:solidFill>
+                <a:latin typeface="Arial"/>
+              </a:rPr>
+              <a:t>•  Tooling &amp; How to Get Help</a:t>
+            </a:r>
+          </a:p>
+          <a:p>
+            <a:pPr>
+              <a:spcAft>
+                <a:spcPts val="500"/>
+              </a:spcAft>
+            </a:pPr>
+            <a:r>
+              <a:rPr sz="1200" b="0" i="0">
+                <a:solidFill>
+                  <a:srgbClr val="1A1A1A"/>
+                </a:solidFill>
+                <a:latin typeface="Arial"/>
+              </a:rPr>
+              <a:t>•  Timeline &amp; Deliverable Clarification</a:t>
+            </a:r>
+          </a:p>
+          <a:p>
+            <a:pPr>
+              <a:spcAft>
+                <a:spcPts val="500"/>
+              </a:spcAft>
+            </a:pPr>
+            <a:r>
+              <a:rPr sz="1200" b="0" i="0">
+                <a:solidFill>
+                  <a:srgbClr val="1A1A1A"/>
+                </a:solidFill>
+                <a:latin typeface="Arial"/>
+              </a:rPr>
+              <a:t>•  Syllabus &amp; Grading Walkthrough</a:t>
+            </a:r>
+          </a:p>
+          <a:p>
+            <a:pPr>
+              <a:spcAft>
+                <a:spcPts val="500"/>
+              </a:spcAft>
+            </a:pPr>
+            <a:r>
+              <a:rPr sz="1200" b="0" i="0">
+                <a:solidFill>
+                  <a:srgbClr val="1A1A1A"/>
+                </a:solidFill>
+                <a:latin typeface="Arial"/>
+              </a:rPr>
+              <a:t>•  Data Sources Discussion (Coincall)</a:t>
+            </a:r>
+          </a:p>
+          <a:p>
+            <a:pPr>
+              <a:spcAft>
+                <a:spcPts val="500"/>
+              </a:spcAft>
+            </a:pPr>
+            <a:r>
+              <a:rPr sz="1200" b="0" i="0">
+                <a:solidFill>
+                  <a:srgbClr val="1A1A1A"/>
+                </a:solidFill>
+                <a:latin typeface="Arial"/>
+              </a:rPr>
+              <a:t>•  Additional Resources -- Math-Heavy Sections</a:t>
+            </a:r>
+          </a:p>
+          <a:p>
+            <a:pPr>
+              <a:spcAft>
+                <a:spcPts val="500"/>
+              </a:spcAft>
+            </a:pPr>
+            <a:r>
+              <a:rPr sz="1200" b="0" i="0">
+                <a:solidFill>
+                  <a:srgbClr val="1A1A1A"/>
+                </a:solidFill>
+                <a:latin typeface="Arial"/>
+              </a:rPr>
+              <a:t>•  Illustration</a:t>
+            </a:r>
+          </a:p>
+          <a:p>
+            <a:pPr>
+              <a:spcAft>
+                <a:spcPts val="500"/>
+              </a:spcAft>
+            </a:pPr>
+            <a:r>
+              <a:rPr sz="1200" b="0" i="0">
+                <a:solidFill>
+                  <a:srgbClr val="1A1A1A"/>
+                </a:solidFill>
+                <a:latin typeface="Arial"/>
+              </a:rPr>
+              <a:t>•  Getting the data from Coincall</a:t>
+            </a:r>
+          </a:p>
+          <a:p>
+            <a:pPr>
+              <a:spcAft>
+                <a:spcPts val="500"/>
+              </a:spcAft>
+            </a:pPr>
+            <a:r>
+              <a:rPr sz="1200" b="0" i="0">
+                <a:solidFill>
+                  <a:srgbClr val="1A1A1A"/>
+                </a:solidFill>
+                <a:latin typeface="Arial"/>
+              </a:rPr>
+              <a:t>•  Code: coincall_client.py</a:t>
+            </a:r>
+          </a:p>
+          <a:p>
+            <a:pPr>
+              <a:spcAft>
+                <a:spcPts val="500"/>
+              </a:spcAft>
+            </a:pPr>
+            <a:r>
+              <a:rPr sz="1200" b="0" i="0">
+                <a:solidFill>
+                  <a:srgbClr val="1A1A1A"/>
+                </a:solidFill>
+                <a:latin typeface="Arial"/>
+              </a:rPr>
+              <a:t>•  Glossary of key terms</a:t>
+            </a:r>
+          </a:p>
+          <a:p>
+            <a:pPr>
+              <a:spcAft>
+                <a:spcPts val="500"/>
+              </a:spcAft>
+            </a:pPr>
+            <a:r>
+              <a:rPr sz="1200" b="0" i="0">
+                <a:solidFill>
+                  <a:srgbClr val="1A1A1A"/>
+                </a:solidFill>
+                <a:latin typeface="Arial"/>
+              </a:rPr>
+              <a:t>•  Reading</a:t>
+            </a:r>
+          </a:p>
+          <a:p>
+            <a:pPr>
+              <a:spcAft>
+                <a:spcPts val="500"/>
+              </a:spcAft>
+            </a:pPr>
+            <a:r>
+              <a:rPr sz="1200" b="0" i="0">
+                <a:solidFill>
+                  <a:srgbClr val="1A1A1A"/>
+                </a:solidFill>
+                <a:latin typeface="Arial"/>
+              </a:rPr>
+              <a:t>•  References</a:t>
             </a:r>
           </a:p>
         </p:txBody>
@@ -5060,7 +5305,7 @@
                 </a:solidFill>
                 <a:latin typeface="Arial"/>
               </a:rPr>
-              <a:t>Where We Are (Week 1 Progress Review)</a:t>
+              <a:t>Learning Objectives</a:t>
             </a:r>
           </a:p>
         </p:txBody>
@@ -5142,7 +5387,7 @@
                 </a:solidFill>
                 <a:latin typeface="Arial"/>
               </a:rPr>
-              <a:t>•  Maker vs. taker: we build the MAKER -- continuously quoting both sides</a:t>
+              <a:t>•  Understand the arc of the program and what you will build</a:t>
             </a:r>
           </a:p>
           <a:p>
@@ -5158,7 +5403,7 @@
                 </a:solidFill>
                 <a:latin typeface="Arial"/>
               </a:rPr>
-              <a:t>•  The spine of the course is the Avellaneda-Stoikov model</a:t>
+              <a:t>•  Be clear on the timeline, the three milestones, and how you are graded</a:t>
             </a:r>
           </a:p>
           <a:p>
@@ -5174,7 +5419,7 @@
                 </a:solidFill>
                 <a:latin typeface="Arial"/>
               </a:rPr>
-              <a:t>•  Week 1 status: environment setup, data access, and this orientation</a:t>
+              <a:t>•  Know where the data comes from (Coincall) and how to pull it</a:t>
             </a:r>
           </a:p>
           <a:p>
@@ -5190,7 +5435,7 @@
                 </a:solidFill>
                 <a:latin typeface="Arial"/>
               </a:rPr>
-              <a:t>•  By Week 5 you ship a calibrated quoting engine (Milestone 1)</a:t>
+              <a:t>•  Have the Python + PyTorch and C++/pybind11 toolchains running</a:t>
             </a:r>
           </a:p>
         </p:txBody>
@@ -5266,7 +5511,7 @@
                 </a:solidFill>
                 <a:latin typeface="Arial"/>
               </a:rPr>
-              <a:t>Tooling &amp; How to Get Help</a:t>
+              <a:t>Where We Are (Week 1 Progress Review)</a:t>
             </a:r>
           </a:p>
         </p:txBody>
@@ -5348,7 +5593,7 @@
                 </a:solidFill>
                 <a:latin typeface="Arial"/>
               </a:rPr>
-              <a:t>•  Problem sets: Python + PyTorch (autograd does differentiation for you)</a:t>
+              <a:t>•  Maker vs. taker: we build the MAKER -- continuously quoting both sides</a:t>
             </a:r>
           </a:p>
           <a:p>
@@ -5364,7 +5609,7 @@
                 </a:solidFill>
                 <a:latin typeface="Arial"/>
               </a:rPr>
-              <a:t>•  Fast computation (Week 7): C++ exposed to Python via pybind11</a:t>
+              <a:t>•  The spine of the course is the Avellaneda-Stoikov model</a:t>
             </a:r>
           </a:p>
           <a:p>
@@ -5380,7 +5625,7 @@
                 </a:solidFill>
                 <a:latin typeface="Arial"/>
               </a:rPr>
-              <a:t>•  Mentorship is asynchronous (email/Telegram); tutors run day-to-day</a:t>
+              <a:t>•  Week 1 status: environment setup, data access, and this orientation</a:t>
             </a:r>
           </a:p>
           <a:p>
@@ -5396,7 +5641,7 @@
                 </a:solidFill>
                 <a:latin typeface="Arial"/>
               </a:rPr>
-              <a:t>•  Office hours with tutors; come with a minimal reproducible snippet</a:t>
+              <a:t>•  By Week 5 you ship a calibrated quoting engine (Milestone 1)</a:t>
             </a:r>
           </a:p>
         </p:txBody>
@@ -5472,7 +5717,7 @@
                 </a:solidFill>
                 <a:latin typeface="Arial"/>
               </a:rPr>
-              <a:t>Timeline &amp; Deliverable Clarification</a:t>
+              <a:t>Tooling &amp; How to Get Help</a:t>
             </a:r>
           </a:p>
         </p:txBody>
@@ -5554,7 +5799,7 @@
                 </a:solidFill>
                 <a:latin typeface="Arial"/>
               </a:rPr>
-              <a:t>•  10 weeks. Week 1 introduction (done). Weeks 2-10 technical.</a:t>
+              <a:t>•  Problem sets: Python + PyTorch (autograd does differentiation for you)</a:t>
             </a:r>
           </a:p>
           <a:p>
@@ -5570,7 +5815,7 @@
                 </a:solidFill>
                 <a:latin typeface="Arial"/>
               </a:rPr>
-              <a:t>•  Milestone 1 (Wk 5): Avellaneda-Stoikov engine, Python/PyTorch</a:t>
+              <a:t>•  Fast computation (Week 7): C++ exposed to Python via pybind11</a:t>
             </a:r>
           </a:p>
           <a:p>
@@ -5586,7 +5831,7 @@
                 </a:solidFill>
                 <a:latin typeface="Arial"/>
               </a:rPr>
-              <a:t>•  Milestone 2 (Wk 7): fast pricing/Greeks library, C++ via pybind11</a:t>
+              <a:t>•  Mentorship is asynchronous (email/Telegram); tutors run day-to-day</a:t>
             </a:r>
           </a:p>
           <a:p>
@@ -5602,39 +5847,7 @@
                 </a:solidFill>
                 <a:latin typeface="Arial"/>
               </a:rPr>
-              <a:t>•  Milestone 3 (Wk 9): full options market-making backtest</a:t>
-            </a:r>
-          </a:p>
-          <a:p>
-            <a:pPr>
-              <a:spcAft>
-                <a:spcPts val="800"/>
-              </a:spcAft>
-            </a:pPr>
-            <a:r>
-              <a:rPr sz="1700" b="0" i="0">
-                <a:solidFill>
-                  <a:srgbClr val="1A1A1A"/>
-                </a:solidFill>
-                <a:latin typeface="Arial"/>
-              </a:rPr>
-              <a:t>•  Final (Wk 10): one advanced extension + report (&lt;=30pp) + 20-min talk</a:t>
-            </a:r>
-          </a:p>
-          <a:p>
-            <a:pPr>
-              <a:spcAft>
-                <a:spcPts val="800"/>
-              </a:spcAft>
-            </a:pPr>
-            <a:r>
-              <a:rPr sz="1700" b="0" i="0">
-                <a:solidFill>
-                  <a:srgbClr val="1A1A1A"/>
-                </a:solidFill>
-                <a:latin typeface="Arial"/>
-              </a:rPr>
-              <a:t>•  Problem sets are due Sunday 23:59 ET; milestones Friday of the week</a:t>
+              <a:t>•  Office hours with tutors; come with a minimal reproducible snippet</a:t>
             </a:r>
           </a:p>
         </p:txBody>
@@ -5710,7 +5923,7 @@
                 </a:solidFill>
                 <a:latin typeface="Arial"/>
               </a:rPr>
-              <a:t>Syllabus &amp; Grading Walkthrough</a:t>
+              <a:t>Timeline &amp; Deliverable Clarification</a:t>
             </a:r>
           </a:p>
         </p:txBody>
@@ -5792,7 +6005,7 @@
                 </a:solidFill>
                 <a:latin typeface="Arial"/>
               </a:rPr>
-              <a:t>•  Problem sets 30%  |  Milestones (3) 30%  |  Final 30%  |  Participation 10%</a:t>
+              <a:t>•  10 weeks. Week 1 introduction (done). Weeks 2-10 technical.</a:t>
             </a:r>
           </a:p>
           <a:p>
@@ -5808,7 +6021,7 @@
                 </a:solidFill>
                 <a:latin typeface="Arial"/>
               </a:rPr>
-              <a:t>•  Code graded on correctness, reproducibility, quality -- in that order</a:t>
+              <a:t>•  Milestone 1 (Wk 5): Avellaneda-Stoikov engine, Python/PyTorch</a:t>
             </a:r>
           </a:p>
           <a:p>
@@ -5824,7 +6037,7 @@
                 </a:solidFill>
                 <a:latin typeface="Arial"/>
               </a:rPr>
-              <a:t>•  Numerical-verification problems: right setup + right error magnitude</a:t>
+              <a:t>•  Milestone 2 (Wk 7): fast pricing/Greeks library, C++ via pybind11</a:t>
             </a:r>
           </a:p>
           <a:p>
@@ -5840,7 +6053,7 @@
                 </a:solidFill>
                 <a:latin typeface="Arial"/>
               </a:rPr>
-              <a:t>•  Milestone 2 latency is a HARD GATE (sub-5ms surface) -- caps at 70 if missed</a:t>
+              <a:t>•  Milestone 3 (Wk 9): full options market-making backtest</a:t>
             </a:r>
           </a:p>
           <a:p>
@@ -5856,7 +6069,7 @@
                 </a:solidFill>
                 <a:latin typeface="Arial"/>
               </a:rPr>
-              <a:t>•  Late PS: -20% until Tue; nothing after. Milestones: no late submission.</a:t>
+              <a:t>•  Final (Wk 10): one advanced extension + report (&lt;=30pp) + 20-min talk</a:t>
             </a:r>
           </a:p>
           <a:p>
@@ -5872,7 +6085,7 @@
                 </a:solidFill>
                 <a:latin typeface="Arial"/>
               </a:rPr>
-              <a:t>•  Set random seeds: reproducibility is explicitly graded</a:t>
+              <a:t>•  Problem sets are due Sunday 23:59 ET; milestones Friday of the week</a:t>
             </a:r>
           </a:p>
         </p:txBody>
@@ -5948,7 +6161,7 @@
                 </a:solidFill>
                 <a:latin typeface="Arial"/>
               </a:rPr>
-              <a:t>Data Sources Discussion (Coincall)</a:t>
+              <a:t>Syllabus &amp; Grading Walkthrough</a:t>
             </a:r>
           </a:p>
         </p:txBody>
@@ -6030,7 +6243,7 @@
                 </a:solidFill>
                 <a:latin typeface="Arial"/>
               </a:rPr>
-              <a:t>•  Exchange: Coincall.  REST base: https://api.coincall.com</a:t>
+              <a:t>•  Problem sets 30%  |  Milestones (3) 30%  |  Final 30%  |  Participation 10%</a:t>
             </a:r>
           </a:p>
           <a:p>
@@ -6046,7 +6259,7 @@
                 </a:solidFill>
                 <a:latin typeface="Arial"/>
               </a:rPr>
-              <a:t>•  Provided as Parquet: BTC/ETH options L2 + trades, perp L2, funding, SVI</a:t>
+              <a:t>•  Code graded on correctness, reproducibility, quality -- in that order</a:t>
             </a:r>
           </a:p>
           <a:p>
@@ -6062,7 +6275,7 @@
                 </a:solidFill>
                 <a:latin typeface="Arial"/>
               </a:rPr>
-              <a:t>•  Coincall orderbook is L2 (aggregated depth) -- there is NO L3 feed</a:t>
+              <a:t>•  Numerical-verification problems: right setup + right error magnitude</a:t>
             </a:r>
           </a:p>
           <a:p>
@@ -6078,7 +6291,7 @@
                 </a:solidFill>
                 <a:latin typeface="Arial"/>
               </a:rPr>
-              <a:t>•  You can also pull live via the REST/WebSocket API (next slides)</a:t>
+              <a:t>•  Milestone 2 latency is a HARD GATE (sub-5ms surface) -- caps at 70 if missed</a:t>
             </a:r>
           </a:p>
           <a:p>
@@ -6094,7 +6307,7 @@
                 </a:solidFill>
                 <a:latin typeface="Arial"/>
               </a:rPr>
-              <a:t>•  Auth: API key + HMAC-SHA256 signature; market data is largely public</a:t>
+              <a:t>•  Late PS: -20% until Tue; nothing after. Milestones: no late submission.</a:t>
             </a:r>
           </a:p>
           <a:p>
@@ -6110,7 +6323,7 @@
                 </a:solidFill>
                 <a:latin typeface="Arial"/>
               </a:rPr>
-              <a:t>•  Always cross-check exact endpoints at https://docs.coincall.com/</a:t>
+              <a:t>•  Set random seeds: reproducibility is explicitly graded</a:t>
             </a:r>
           </a:p>
         </p:txBody>
@@ -6186,7 +6399,7 @@
                 </a:solidFill>
                 <a:latin typeface="Arial"/>
               </a:rPr>
-              <a:t>Additional Resources -- Math-Heavy Sections</a:t>
+              <a:t>Data Sources Discussion (Coincall)</a:t>
             </a:r>
           </a:p>
         </p:txBody>
@@ -6268,7 +6481,7 @@
                 </a:solidFill>
                 <a:latin typeface="Arial"/>
               </a:rPr>
-              <a:t>•  Stochastic control: Pham (2009), Ch. 3-4 (HJB, verification)</a:t>
+              <a:t>•  Exchange: Coincall.  REST base: https://api.coincall.com</a:t>
             </a:r>
           </a:p>
           <a:p>
@@ -6284,7 +6497,7 @@
                 </a:solidFill>
                 <a:latin typeface="Arial"/>
               </a:rPr>
-              <a:t>•  Market making theory: Gueant (2016), Ch. 4; Cartea et al., Ch. 10-11</a:t>
+              <a:t>•  Provided as Parquet: BTC/ETH options L2 + trades, perp L2, funding, SVI</a:t>
             </a:r>
           </a:p>
           <a:p>
@@ -6300,7 +6513,7 @@
                 </a:solidFill>
                 <a:latin typeface="Arial"/>
               </a:rPr>
-              <a:t>•  Options/vol surface: Gatheral (2006); Gatheral-Jacquier (2014)</a:t>
+              <a:t>•  Coincall orderbook is L2 (aggregated depth) -- there is NO L3 feed</a:t>
             </a:r>
           </a:p>
           <a:p>
@@ -6316,7 +6529,7 @@
                 </a:solidFill>
                 <a:latin typeface="Arial"/>
               </a:rPr>
-              <a:t>•  Hedging: Taleb (1997), gamma scalping &amp; the gamma-theta identity</a:t>
+              <a:t>•  You can also pull live via the REST/WebSocket API (next slides)</a:t>
             </a:r>
           </a:p>
           <a:p>
@@ -6332,7 +6545,7 @@
                 </a:solidFill>
                 <a:latin typeface="Arial"/>
               </a:rPr>
-              <a:t>•  El Aoud-Abergel (2015): multi-Greek option market making (Week 8)</a:t>
+              <a:t>•  Auth: API key + HMAC-SHA256 signature; market data is largely public</a:t>
             </a:r>
           </a:p>
           <a:p>
@@ -6348,7 +6561,7 @@
                 </a:solidFill>
                 <a:latin typeface="Arial"/>
               </a:rPr>
-              <a:t>•  We DERIVE the key results in lecture and explain every modeling choice</a:t>
+              <a:t>•  Always cross-check exact endpoints at https://docs.coincall.com/</a:t>
             </a:r>
           </a:p>
         </p:txBody>
@@ -6387,7 +6600,7 @@
         </p:blipFill>
         <p:spPr>
           <a:xfrm>
-            <a:off x="9784080" y="228600"/>
+            <a:off x="9784080" y="274320"/>
             <a:ext cx="2011680" cy="316653"/>
           </a:xfrm>
           <a:prstGeom prst="rect">
@@ -6403,8 +6616,8 @@
         </p:nvSpPr>
         <p:spPr>
           <a:xfrm>
-            <a:off x="457200" y="411480"/>
-            <a:ext cx="8961120" cy="731520"/>
+            <a:off x="457200" y="457200"/>
+            <a:ext cx="8961120" cy="822960"/>
           </a:xfrm>
           <a:prstGeom prst="rect">
             <a:avLst/>
@@ -6412,47 +6625,185 @@
           <a:noFill/>
         </p:spPr>
         <p:txBody>
-          <a:bodyPr wrap="none">
+          <a:bodyPr wrap="square">
             <a:spAutoFit/>
           </a:bodyPr>
           <a:lstStyle/>
           <a:p>
             <a:r>
-              <a:rPr sz="2200" b="1" i="0">
+              <a:rPr sz="2400" b="1" i="0">
                 <a:solidFill>
                   <a:srgbClr val="990000"/>
                 </a:solidFill>
                 <a:latin typeface="Arial"/>
               </a:rPr>
-              <a:t>Illustration</a:t>
-            </a:r>
-          </a:p>
-        </p:txBody>
-      </p:sp>
-      <p:pic>
-        <p:nvPicPr>
-          <p:cNvPr id="4" name="Picture 3" descr="week01.png"/>
-          <p:cNvPicPr>
-            <a:picLocks noChangeAspect="1"/>
-          </p:cNvPicPr>
+              <a:t>Additional Resources -- Math-Heavy Sections</a:t>
+            </a:r>
+          </a:p>
+        </p:txBody>
+      </p:sp>
+      <p:sp>
+        <p:nvSpPr>
+          <p:cNvPr id="4" name="Rectangle 3"/>
+          <p:cNvSpPr/>
           <p:nvPr/>
-        </p:nvPicPr>
-        <p:blipFill>
-          <a:blip r:embed="rId3"/>
-          <a:stretch>
-            <a:fillRect/>
-          </a:stretch>
-        </p:blipFill>
-        <p:spPr>
-          <a:xfrm>
-            <a:off x="1280160" y="1371600"/>
-            <a:ext cx="9601200" cy="5249525"/>
+        </p:nvSpPr>
+        <p:spPr>
+          <a:xfrm>
+            <a:off x="457200" y="1371600"/>
+            <a:ext cx="11247120" cy="27940"/>
           </a:xfrm>
           <a:prstGeom prst="rect">
             <a:avLst/>
           </a:prstGeom>
-        </p:spPr>
-      </p:pic>
+          <a:solidFill>
+            <a:srgbClr val="CC0000"/>
+          </a:solidFill>
+          <a:ln>
+            <a:noFill/>
+          </a:ln>
+        </p:spPr>
+        <p:style>
+          <a:lnRef idx="1">
+            <a:schemeClr val="accent1"/>
+          </a:lnRef>
+          <a:fillRef idx="3">
+            <a:schemeClr val="accent1"/>
+          </a:fillRef>
+          <a:effectRef idx="2">
+            <a:schemeClr val="accent1"/>
+          </a:effectRef>
+          <a:fontRef idx="minor">
+            <a:schemeClr val="lt1"/>
+          </a:fontRef>
+        </p:style>
+        <p:txBody>
+          <a:bodyPr rtlCol="0" anchor="ctr"/>
+          <a:lstStyle/>
+          <a:p>
+            <a:pPr algn="ctr"/>
+          </a:p>
+        </p:txBody>
+      </p:sp>
+      <p:sp>
+        <p:nvSpPr>
+          <p:cNvPr id="5" name="TextBox 4"/>
+          <p:cNvSpPr txBox="1"/>
+          <p:nvPr/>
+        </p:nvSpPr>
+        <p:spPr>
+          <a:xfrm>
+            <a:off x="640080" y="1600200"/>
+            <a:ext cx="10972800" cy="4937760"/>
+          </a:xfrm>
+          <a:prstGeom prst="rect">
+            <a:avLst/>
+          </a:prstGeom>
+          <a:noFill/>
+        </p:spPr>
+        <p:txBody>
+          <a:bodyPr wrap="square">
+            <a:spAutoFit/>
+          </a:bodyPr>
+          <a:lstStyle/>
+          <a:p>
+            <a:pPr>
+              <a:spcAft>
+                <a:spcPts val="800"/>
+              </a:spcAft>
+            </a:pPr>
+            <a:r>
+              <a:rPr sz="1700" b="0" i="0">
+                <a:solidFill>
+                  <a:srgbClr val="1A1A1A"/>
+                </a:solidFill>
+                <a:latin typeface="Arial"/>
+              </a:rPr>
+              <a:t>•  Stochastic control: Pham (2009), Ch. 3-4 (HJB, verification)</a:t>
+            </a:r>
+          </a:p>
+          <a:p>
+            <a:pPr>
+              <a:spcAft>
+                <a:spcPts val="800"/>
+              </a:spcAft>
+            </a:pPr>
+            <a:r>
+              <a:rPr sz="1700" b="0" i="0">
+                <a:solidFill>
+                  <a:srgbClr val="1A1A1A"/>
+                </a:solidFill>
+                <a:latin typeface="Arial"/>
+              </a:rPr>
+              <a:t>•  Market making theory: Gueant (2016), Ch. 4; Cartea et al., Ch. 10-11</a:t>
+            </a:r>
+          </a:p>
+          <a:p>
+            <a:pPr>
+              <a:spcAft>
+                <a:spcPts val="800"/>
+              </a:spcAft>
+            </a:pPr>
+            <a:r>
+              <a:rPr sz="1700" b="0" i="0">
+                <a:solidFill>
+                  <a:srgbClr val="1A1A1A"/>
+                </a:solidFill>
+                <a:latin typeface="Arial"/>
+              </a:rPr>
+              <a:t>•  Options/vol surface: Gatheral (2006); Gatheral-Jacquier (2014)</a:t>
+            </a:r>
+          </a:p>
+          <a:p>
+            <a:pPr>
+              <a:spcAft>
+                <a:spcPts val="800"/>
+              </a:spcAft>
+            </a:pPr>
+            <a:r>
+              <a:rPr sz="1700" b="0" i="0">
+                <a:solidFill>
+                  <a:srgbClr val="1A1A1A"/>
+                </a:solidFill>
+                <a:latin typeface="Arial"/>
+              </a:rPr>
+              <a:t>•  Hedging: Taleb (1997), gamma scalping &amp; the gamma-theta identity</a:t>
+            </a:r>
+          </a:p>
+          <a:p>
+            <a:pPr>
+              <a:spcAft>
+                <a:spcPts val="800"/>
+              </a:spcAft>
+            </a:pPr>
+            <a:r>
+              <a:rPr sz="1700" b="0" i="0">
+                <a:solidFill>
+                  <a:srgbClr val="1A1A1A"/>
+                </a:solidFill>
+                <a:latin typeface="Arial"/>
+              </a:rPr>
+              <a:t>•  El Aoud-Abergel (2015): multi-Greek option market making (Week 8)</a:t>
+            </a:r>
+          </a:p>
+          <a:p>
+            <a:pPr>
+              <a:spcAft>
+                <a:spcPts val="800"/>
+              </a:spcAft>
+            </a:pPr>
+            <a:r>
+              <a:rPr sz="1700" b="0" i="0">
+                <a:solidFill>
+                  <a:srgbClr val="1A1A1A"/>
+                </a:solidFill>
+                <a:latin typeface="Arial"/>
+              </a:rPr>
+              <a:t>•  We DERIVE the key results in lecture and explain every modeling choice</a:t>
+            </a:r>
+          </a:p>
+        </p:txBody>
+      </p:sp>
     </p:spTree>
   </p:cSld>
   <p:clrMapOvr>

</xml_diff>